<commit_message>
Align recap slide design
</commit_message>
<xml_diff>
--- a/FGD_Recap_by_region_CN_editable.pptx
+++ b/FGD_Recap_by_region_CN_editable.pptx
@@ -3397,10 +3397,10 @@
       </p:sp>
       <p:sp>
         <p:nvSpPr>
-          <p:cNvPr id="3" name="文本框 2">
-            <a:extLst>
-              <a:ext uri="{FF2B5EF4-FFF2-40B4-BE49-F238E27FC236}">
-                <a16:creationId xmlns:a16="http://schemas.microsoft.com/office/drawing/2014/main" id="{FB77223B-67D9-DABA-0A14-EC44A89274ED}"/>
+          <p:cNvPr id="4" name="文本框 3">
+            <a:extLst>
+              <a:ext uri="{FF2B5EF4-FFF2-40B4-BE49-F238E27FC236}">
+                <a16:creationId xmlns:a16="http://schemas.microsoft.com/office/drawing/2014/main" id="{EB6ADCB3-DBE4-D852-2032-797DFE6F77C8}"/>
               </a:ext>
             </a:extLst>
           </p:cNvPr>
@@ -3409,8 +3409,8 @@
         </p:nvSpPr>
         <p:spPr>
           <a:xfrm>
-            <a:off x="596900" y="228600"/>
-            <a:ext cx="1651000" cy="169277"/>
+            <a:off x="571500" y="482600"/>
+            <a:ext cx="4826000" cy="477054"/>
           </a:xfrm>
           <a:prstGeom prst="rect">
             <a:avLst/>
@@ -3424,58 +3424,17 @@
           <a:lstStyle/>
           <a:p>
             <a:r>
-              <a:rPr lang="zh-CN" altLang="en-US" sz="1100" b="1">
-                <a:solidFill>
-                  <a:srgbClr val="FF5F32"/>
+              <a:rPr lang="zh-CN" altLang="en-US" sz="3100" b="1" dirty="0">
+                <a:solidFill>
+                  <a:srgbClr val="F8F6EF"/>
                 </a:solidFill>
                 <a:latin typeface="Microsoft YaHei UI" panose="020B0503020204020204" pitchFamily="34" charset="-122"/>
                 <a:ea typeface="Microsoft YaHei UI" panose="020B0503020204020204" pitchFamily="34" charset="-122"/>
               </a:rPr>
-              <a:t>焦点小组调研</a:t>
-            </a:r>
-          </a:p>
-        </p:txBody>
-      </p:sp>
-      <p:sp>
-        <p:nvSpPr>
-          <p:cNvPr id="4" name="文本框 3">
-            <a:extLst>
-              <a:ext uri="{FF2B5EF4-FFF2-40B4-BE49-F238E27FC236}">
-                <a16:creationId xmlns:a16="http://schemas.microsoft.com/office/drawing/2014/main" id="{EB6ADCB3-DBE4-D852-2032-797DFE6F77C8}"/>
-              </a:ext>
-            </a:extLst>
-          </p:cNvPr>
-          <p:cNvSpPr txBox="1"/>
-          <p:nvPr/>
-        </p:nvSpPr>
-        <p:spPr>
-          <a:xfrm>
-            <a:off x="571500" y="482600"/>
-            <a:ext cx="4826000" cy="477054"/>
-          </a:xfrm>
-          <a:prstGeom prst="rect">
-            <a:avLst/>
-          </a:prstGeom>
-          <a:noFill/>
-        </p:spPr>
-        <p:txBody>
-          <a:bodyPr vert="horz" wrap="square" lIns="0" tIns="0" rIns="0" bIns="0" rtlCol="0">
-            <a:spAutoFit/>
-          </a:bodyPr>
-          <a:lstStyle/>
-          <a:p>
-            <a:r>
-              <a:rPr lang="zh-CN" altLang="en-US" sz="3100" b="1">
-                <a:solidFill>
-                  <a:srgbClr val="F8F6EF"/>
-                </a:solidFill>
-                <a:latin typeface="Microsoft YaHei UI" panose="020B0503020204020204" pitchFamily="34" charset="-122"/>
-                <a:ea typeface="Microsoft YaHei UI" panose="020B0503020204020204" pitchFamily="34" charset="-122"/>
-              </a:rPr>
-              <a:t>三地 </a:t>
-            </a:r>
-            <a:r>
-              <a:rPr lang="en-US" altLang="zh-CN" sz="3100" b="1">
+              <a:t>全区</a:t>
+            </a:r>
+            <a:r>
+              <a:rPr lang="en-US" altLang="zh-CN" sz="3100" b="1" dirty="0">
                 <a:solidFill>
                   <a:srgbClr val="F8F6EF"/>
                 </a:solidFill>
@@ -3485,7 +3444,7 @@
               <a:t>FGD </a:t>
             </a:r>
             <a:r>
-              <a:rPr lang="zh-CN" altLang="en-US" sz="3100" b="1">
+              <a:rPr lang="zh-CN" altLang="en-US" sz="3100" b="1" dirty="0">
                 <a:solidFill>
                   <a:srgbClr val="F8F6EF"/>
                 </a:solidFill>
@@ -3493,47 +3452,6 @@
                 <a:ea typeface="Microsoft YaHei UI" panose="020B0503020204020204" pitchFamily="34" charset="-122"/>
               </a:rPr>
               <a:t>现场回顾</a:t>
-            </a:r>
-          </a:p>
-        </p:txBody>
-      </p:sp>
-      <p:sp>
-        <p:nvSpPr>
-          <p:cNvPr id="5" name="文本框 4">
-            <a:extLst>
-              <a:ext uri="{FF2B5EF4-FFF2-40B4-BE49-F238E27FC236}">
-                <a16:creationId xmlns:a16="http://schemas.microsoft.com/office/drawing/2014/main" id="{8F217CB2-89A2-BED4-8432-455842F6F022}"/>
-              </a:ext>
-            </a:extLst>
-          </p:cNvPr>
-          <p:cNvSpPr txBox="1"/>
-          <p:nvPr/>
-        </p:nvSpPr>
-        <p:spPr>
-          <a:xfrm>
-            <a:off x="596900" y="952500"/>
-            <a:ext cx="4699000" cy="230832"/>
-          </a:xfrm>
-          <a:prstGeom prst="rect">
-            <a:avLst/>
-          </a:prstGeom>
-          <a:noFill/>
-        </p:spPr>
-        <p:txBody>
-          <a:bodyPr vert="horz" wrap="square" lIns="0" tIns="0" rIns="0" bIns="0" rtlCol="0">
-            <a:spAutoFit/>
-          </a:bodyPr>
-          <a:lstStyle/>
-          <a:p>
-            <a:r>
-              <a:rPr lang="zh-CN" altLang="en-US" sz="1500">
-                <a:solidFill>
-                  <a:srgbClr val="B9C3CB"/>
-                </a:solidFill>
-                <a:latin typeface="Microsoft YaHei UI" panose="020B0503020204020204" pitchFamily="34" charset="-122"/>
-                <a:ea typeface="Microsoft YaHei UI" panose="020B0503020204020204" pitchFamily="34" charset="-122"/>
-              </a:rPr>
-              <a:t>按地区整理现场试玩、观察与访谈照片</a:t>
             </a:r>
           </a:p>
         </p:txBody>
@@ -5207,10 +5125,10 @@
       </p:grpSpPr>
       <p:sp>
         <p:nvSpPr>
-          <p:cNvPr id="6" name="矩形 5">
-            <a:extLst>
-              <a:ext uri="{FF2B5EF4-FFF2-40B4-BE49-F238E27FC236}">
-                <a16:creationId xmlns:a16="http://schemas.microsoft.com/office/drawing/2014/main" id="{3B23B5C1-812B-852F-E920-FC27CF0EFCCD}"/>
+          <p:cNvPr id="16" name="矩形 15">
+            <a:extLst>
+              <a:ext uri="{FF2B5EF4-FFF2-40B4-BE49-F238E27FC236}">
+                <a16:creationId xmlns:a16="http://schemas.microsoft.com/office/drawing/2014/main" id="{805BF741-53E8-8B78-3E03-D239634C5D53}"/>
               </a:ext>
             </a:extLst>
           </p:cNvPr>
@@ -5226,7 +5144,7 @@
             <a:avLst/>
           </a:prstGeom>
           <a:solidFill>
-            <a:srgbClr val="F5F0E8"/>
+            <a:srgbClr val="070B10"/>
           </a:solidFill>
           <a:ln w="19050" cap="flat" cmpd="sng" algn="ctr">
             <a:noFill/>
@@ -5275,10 +5193,10 @@
       </p:sp>
       <p:sp>
         <p:nvSpPr>
-          <p:cNvPr id="8" name="文本框 7">
-            <a:extLst>
-              <a:ext uri="{FF2B5EF4-FFF2-40B4-BE49-F238E27FC236}">
-                <a16:creationId xmlns:a16="http://schemas.microsoft.com/office/drawing/2014/main" id="{A9826CB7-2E58-D0B5-2FD3-DA33012CE2C4}"/>
+          <p:cNvPr id="49" name="文本框 48">
+            <a:extLst>
+              <a:ext uri="{FF2B5EF4-FFF2-40B4-BE49-F238E27FC236}">
+                <a16:creationId xmlns:a16="http://schemas.microsoft.com/office/drawing/2014/main" id="{7402A278-E170-1811-1E05-C523E8AD66D9}"/>
               </a:ext>
             </a:extLst>
           </p:cNvPr>
@@ -5287,8 +5205,8 @@
         </p:nvSpPr>
         <p:spPr>
           <a:xfrm>
-            <a:off x="609600" y="431800"/>
-            <a:ext cx="10985500" cy="323165"/>
+            <a:off x="571500" y="609600"/>
+            <a:ext cx="9652000" cy="507831"/>
           </a:xfrm>
           <a:prstGeom prst="rect">
             <a:avLst/>
@@ -5302,39 +5220,60 @@
           <a:lstStyle/>
           <a:p>
             <a:r>
-              <a:rPr lang="zh-CN" altLang="en-US" sz="2100" b="1">
-                <a:solidFill>
-                  <a:srgbClr val="1E252C"/>
+              <a:rPr lang="zh-CN" altLang="en-US" sz="3300" b="1">
+                <a:solidFill>
+                  <a:srgbClr val="F8F6EF"/>
                 </a:solidFill>
                 <a:latin typeface="Microsoft YaHei UI" panose="020B0503020204020204" pitchFamily="34" charset="-122"/>
                 <a:ea typeface="Microsoft YaHei UI" panose="020B0503020204020204" pitchFamily="34" charset="-122"/>
               </a:rPr>
-              <a:t>全区 </a:t>
-            </a:r>
-            <a:r>
-              <a:rPr lang="en-US" altLang="zh-CN" sz="2100" b="1">
-                <a:solidFill>
-                  <a:srgbClr val="1E252C"/>
+              <a:t>操控得到全面积极反馈！</a:t>
+            </a:r>
+          </a:p>
+        </p:txBody>
+      </p:sp>
+      <p:sp>
+        <p:nvSpPr>
+          <p:cNvPr id="50" name="文本框 49">
+            <a:extLst>
+              <a:ext uri="{FF2B5EF4-FFF2-40B4-BE49-F238E27FC236}">
+                <a16:creationId xmlns:a16="http://schemas.microsoft.com/office/drawing/2014/main" id="{D4985004-F81A-185D-E038-DA60BC22F14C}"/>
+              </a:ext>
+            </a:extLst>
+          </p:cNvPr>
+          <p:cNvSpPr txBox="1"/>
+          <p:nvPr/>
+        </p:nvSpPr>
+        <p:spPr>
+          <a:xfrm>
+            <a:off x="596900" y="1333500"/>
+            <a:ext cx="10541000" cy="307777"/>
+          </a:xfrm>
+          <a:prstGeom prst="rect">
+            <a:avLst/>
+          </a:prstGeom>
+          <a:noFill/>
+        </p:spPr>
+        <p:txBody>
+          <a:bodyPr vert="horz" wrap="square" lIns="0" tIns="0" rIns="0" bIns="0" rtlCol="0">
+            <a:spAutoFit/>
+          </a:bodyPr>
+          <a:lstStyle/>
+          <a:p>
+            <a:r>
+              <a:rPr lang="zh-CN" altLang="en-US" sz="2000" dirty="0">
+                <a:solidFill>
+                  <a:srgbClr val="B9C3CB"/>
                 </a:solidFill>
                 <a:latin typeface="Microsoft YaHei UI" panose="020B0503020204020204" pitchFamily="34" charset="-122"/>
                 <a:ea typeface="Microsoft YaHei UI" panose="020B0503020204020204" pitchFamily="34" charset="-122"/>
               </a:rPr>
-              <a:t>FGD </a:t>
-            </a:r>
-            <a:r>
-              <a:rPr lang="zh-CN" altLang="en-US" sz="2100" b="1">
-                <a:solidFill>
-                  <a:srgbClr val="1E252C"/>
-                </a:solidFill>
-                <a:latin typeface="Microsoft YaHei UI" panose="020B0503020204020204" pitchFamily="34" charset="-122"/>
-                <a:ea typeface="Microsoft YaHei UI" panose="020B0503020204020204" pitchFamily="34" charset="-122"/>
-              </a:rPr>
-              <a:t>总结：新 </a:t>
-            </a:r>
-            <a:r>
-              <a:rPr lang="en-US" altLang="zh-CN" sz="2100" b="1">
-                <a:solidFill>
-                  <a:srgbClr val="1E252C"/>
+              <a:t>新 </a:t>
+            </a:r>
+            <a:r>
+              <a:rPr lang="en-US" altLang="zh-CN" sz="2000" dirty="0">
+                <a:solidFill>
+                  <a:srgbClr val="B9C3CB"/>
                 </a:solidFill>
                 <a:latin typeface="Microsoft YaHei UI" panose="020B0503020204020204" pitchFamily="34" charset="-122"/>
                 <a:ea typeface="Microsoft YaHei UI" panose="020B0503020204020204" pitchFamily="34" charset="-122"/>
@@ -5342,24 +5281,24 @@
               <a:t>3C </a:t>
             </a:r>
             <a:r>
-              <a:rPr lang="zh-CN" altLang="en-US" sz="2100" b="1">
-                <a:solidFill>
-                  <a:srgbClr val="1E252C"/>
+              <a:rPr lang="zh-CN" altLang="en-US" sz="2000" dirty="0">
+                <a:solidFill>
+                  <a:srgbClr val="B9C3CB"/>
                 </a:solidFill>
                 <a:latin typeface="Microsoft YaHei UI" panose="020B0503020204020204" pitchFamily="34" charset="-122"/>
                 <a:ea typeface="Microsoft YaHei UI" panose="020B0503020204020204" pitchFamily="34" charset="-122"/>
               </a:rPr>
-              <a:t>有吸引力，但老玩家担心核心体验变浅</a:t>
-            </a:r>
-          </a:p>
-        </p:txBody>
-      </p:sp>
-      <p:sp>
-        <p:nvSpPr>
-          <p:cNvPr id="10" name="矩形: 圆角 9">
-            <a:extLst>
-              <a:ext uri="{FF2B5EF4-FFF2-40B4-BE49-F238E27FC236}">
-                <a16:creationId xmlns:a16="http://schemas.microsoft.com/office/drawing/2014/main" id="{CB3B8948-0B0C-7892-D682-CE128C7E1AE1}"/>
+              <a:t>的战斗体验在新玩家侧得到认可，但多数老玩家担心战斗策略由于镜头改变而变浅</a:t>
+            </a:r>
+          </a:p>
+        </p:txBody>
+      </p:sp>
+      <p:sp>
+        <p:nvSpPr>
+          <p:cNvPr id="58" name="矩形: 圆角 57">
+            <a:extLst>
+              <a:ext uri="{FF2B5EF4-FFF2-40B4-BE49-F238E27FC236}">
+                <a16:creationId xmlns:a16="http://schemas.microsoft.com/office/drawing/2014/main" id="{F0359324-62BA-9AF6-60AE-7E7D77253663}"/>
               </a:ext>
             </a:extLst>
           </p:cNvPr>
@@ -5368,20 +5307,20 @@
         </p:nvSpPr>
         <p:spPr>
           <a:xfrm>
-            <a:off x="609600" y="1066800"/>
-            <a:ext cx="10985500" cy="698500"/>
+            <a:off x="609600" y="2108200"/>
+            <a:ext cx="5181600" cy="3886200"/>
           </a:xfrm>
           <a:prstGeom prst="roundRect">
             <a:avLst>
-              <a:gd name="adj" fmla="val 12000"/>
+              <a:gd name="adj" fmla="val 10000"/>
             </a:avLst>
           </a:prstGeom>
           <a:solidFill>
-            <a:srgbClr val="FFFFFF"/>
+            <a:srgbClr val="101820"/>
           </a:solidFill>
           <a:ln w="12700">
             <a:solidFill>
-              <a:srgbClr val="DED3C5"/>
+              <a:srgbClr val="33414E"/>
             </a:solidFill>
           </a:ln>
         </p:spPr>
@@ -5412,10 +5351,10 @@
       </p:sp>
       <p:sp>
         <p:nvSpPr>
-          <p:cNvPr id="12" name="椭圆 11">
-            <a:extLst>
-              <a:ext uri="{FF2B5EF4-FFF2-40B4-BE49-F238E27FC236}">
-                <a16:creationId xmlns:a16="http://schemas.microsoft.com/office/drawing/2014/main" id="{B402227A-43B9-338D-190A-9FCF4838C963}"/>
+          <p:cNvPr id="59" name="矩形 58">
+            <a:extLst>
+              <a:ext uri="{FF2B5EF4-FFF2-40B4-BE49-F238E27FC236}">
+                <a16:creationId xmlns:a16="http://schemas.microsoft.com/office/drawing/2014/main" id="{FA40635D-86DE-B578-2C6E-CD2F30F98A24}"/>
               </a:ext>
             </a:extLst>
           </p:cNvPr>
@@ -5424,14 +5363,14 @@
         </p:nvSpPr>
         <p:spPr>
           <a:xfrm>
-            <a:off x="889000" y="1308100"/>
-            <a:ext cx="228600" cy="228600"/>
-          </a:xfrm>
-          <a:prstGeom prst="ellipse">
+            <a:off x="609600" y="2108200"/>
+            <a:ext cx="88900" cy="3886200"/>
+          </a:xfrm>
+          <a:prstGeom prst="rect">
             <a:avLst/>
           </a:prstGeom>
           <a:solidFill>
-            <a:srgbClr val="30C2C9"/>
+            <a:srgbClr val="1DAE9C"/>
           </a:solidFill>
           <a:ln w="19050" cap="flat" cmpd="sng" algn="ctr">
             <a:noFill/>
@@ -5480,197 +5419,46 @@
       </p:sp>
       <p:sp>
         <p:nvSpPr>
-          <p:cNvPr id="14" name="文本框 13">
-            <a:extLst>
-              <a:ext uri="{FF2B5EF4-FFF2-40B4-BE49-F238E27FC236}">
-                <a16:creationId xmlns:a16="http://schemas.microsoft.com/office/drawing/2014/main" id="{399DE73D-C1E6-9FE6-7E51-8C7A020B0B11}"/>
-              </a:ext>
-            </a:extLst>
-          </p:cNvPr>
-          <p:cNvSpPr txBox="1"/>
+          <p:cNvPr id="60" name="椭圆 59">
+            <a:extLst>
+              <a:ext uri="{FF2B5EF4-FFF2-40B4-BE49-F238E27FC236}">
+                <a16:creationId xmlns:a16="http://schemas.microsoft.com/office/drawing/2014/main" id="{D9301102-0F9D-B5A3-B897-C41492351153}"/>
+              </a:ext>
+            </a:extLst>
+          </p:cNvPr>
+          <p:cNvSpPr/>
           <p:nvPr/>
         </p:nvSpPr>
         <p:spPr>
           <a:xfrm>
-            <a:off x="1244600" y="1244600"/>
-            <a:ext cx="889000" cy="184666"/>
-          </a:xfrm>
-          <a:prstGeom prst="rect">
+            <a:off x="863600" y="2438400"/>
+            <a:ext cx="127000" cy="127000"/>
+          </a:xfrm>
+          <a:prstGeom prst="ellipse">
             <a:avLst/>
           </a:prstGeom>
-          <a:noFill/>
-        </p:spPr>
-        <p:txBody>
-          <a:bodyPr vert="horz" wrap="square" lIns="0" tIns="0" rIns="0" bIns="0" rtlCol="0">
-            <a:spAutoFit/>
-          </a:bodyPr>
-          <a:lstStyle/>
-          <a:p>
-            <a:r>
-              <a:rPr lang="zh-CN" altLang="en-US" sz="1200" b="1">
-                <a:solidFill>
-                  <a:srgbClr val="2183A3"/>
-                </a:solidFill>
-                <a:latin typeface="Microsoft YaHei UI" panose="020B0503020204020204" pitchFamily="34" charset="-122"/>
-                <a:ea typeface="Microsoft YaHei UI" panose="020B0503020204020204" pitchFamily="34" charset="-122"/>
-              </a:rPr>
-              <a:t>总判断</a:t>
-            </a:r>
-          </a:p>
-        </p:txBody>
-      </p:sp>
-      <p:sp>
-        <p:nvSpPr>
-          <p:cNvPr id="16" name="文本框 15">
-            <a:extLst>
-              <a:ext uri="{FF2B5EF4-FFF2-40B4-BE49-F238E27FC236}">
-                <a16:creationId xmlns:a16="http://schemas.microsoft.com/office/drawing/2014/main" id="{403655B8-458D-C15F-F60F-E784FEF2C604}"/>
-              </a:ext>
-            </a:extLst>
-          </p:cNvPr>
-          <p:cNvSpPr txBox="1"/>
-          <p:nvPr/>
-        </p:nvSpPr>
-        <p:spPr>
-          <a:xfrm>
-            <a:off x="2159000" y="1231900"/>
-            <a:ext cx="8636000" cy="207749"/>
-          </a:xfrm>
-          <a:prstGeom prst="rect">
-            <a:avLst/>
-          </a:prstGeom>
-          <a:noFill/>
-        </p:spPr>
-        <p:txBody>
-          <a:bodyPr vert="horz" wrap="square" lIns="0" tIns="0" rIns="0" bIns="0" rtlCol="0">
-            <a:spAutoFit/>
-          </a:bodyPr>
-          <a:lstStyle/>
-          <a:p>
-            <a:r>
-              <a:rPr lang="zh-CN" altLang="en-US" sz="1350" b="1">
-                <a:solidFill>
-                  <a:srgbClr val="1E252C"/>
-                </a:solidFill>
-                <a:latin typeface="Microsoft YaHei UI" panose="020B0503020204020204" pitchFamily="34" charset="-122"/>
-                <a:ea typeface="Microsoft YaHei UI" panose="020B0503020204020204" pitchFamily="34" charset="-122"/>
-              </a:rPr>
-              <a:t>新版本 </a:t>
-            </a:r>
-            <a:r>
-              <a:rPr lang="en-US" altLang="zh-CN" sz="1350" b="1">
-                <a:solidFill>
-                  <a:srgbClr val="1E252C"/>
-                </a:solidFill>
-                <a:latin typeface="Microsoft YaHei UI" panose="020B0503020204020204" pitchFamily="34" charset="-122"/>
-                <a:ea typeface="Microsoft YaHei UI" panose="020B0503020204020204" pitchFamily="34" charset="-122"/>
-              </a:rPr>
-              <a:t>3C </a:t>
-            </a:r>
-            <a:r>
-              <a:rPr lang="zh-CN" altLang="en-US" sz="1350" b="1">
-                <a:solidFill>
-                  <a:srgbClr val="1E252C"/>
-                </a:solidFill>
-                <a:latin typeface="Microsoft YaHei UI" panose="020B0503020204020204" pitchFamily="34" charset="-122"/>
-                <a:ea typeface="Microsoft YaHei UI" panose="020B0503020204020204" pitchFamily="34" charset="-122"/>
-              </a:rPr>
-              <a:t>的“打斗吸引力”已被认可，但“搜打撤闭环”仍需后续验证。</a:t>
-            </a:r>
-          </a:p>
-        </p:txBody>
-      </p:sp>
-      <p:sp>
-        <p:nvSpPr>
-          <p:cNvPr id="66" name="文本框 65">
-            <a:extLst>
-              <a:ext uri="{FF2B5EF4-FFF2-40B4-BE49-F238E27FC236}">
-                <a16:creationId xmlns:a16="http://schemas.microsoft.com/office/drawing/2014/main" id="{F0581A53-C453-ED8F-FB11-AD9DCD9B44FE}"/>
-              </a:ext>
-            </a:extLst>
-          </p:cNvPr>
-          <p:cNvSpPr txBox="1"/>
-          <p:nvPr/>
-        </p:nvSpPr>
-        <p:spPr>
-          <a:xfrm>
-            <a:off x="2159000" y="1511300"/>
-            <a:ext cx="8636000" cy="153888"/>
-          </a:xfrm>
-          <a:prstGeom prst="rect">
-            <a:avLst/>
-          </a:prstGeom>
-          <a:noFill/>
-        </p:spPr>
-        <p:txBody>
-          <a:bodyPr vert="horz" wrap="square" lIns="0" tIns="0" rIns="0" bIns="0" rtlCol="0">
-            <a:spAutoFit/>
-          </a:bodyPr>
-          <a:lstStyle/>
-          <a:p>
-            <a:r>
-              <a:rPr lang="zh-CN" altLang="en-US" sz="1000">
-                <a:solidFill>
-                  <a:srgbClr val="64707A"/>
-                </a:solidFill>
-                <a:latin typeface="Microsoft YaHei UI" panose="020B0503020204020204" pitchFamily="34" charset="-122"/>
-                <a:ea typeface="Microsoft YaHei UI" panose="020B0503020204020204" pitchFamily="34" charset="-122"/>
-              </a:rPr>
-              <a:t>新玩家想进来，老玩家怕失去 </a:t>
-            </a:r>
-            <a:r>
-              <a:rPr lang="en-US" altLang="zh-CN" sz="1000">
-                <a:solidFill>
-                  <a:srgbClr val="64707A"/>
-                </a:solidFill>
-                <a:latin typeface="Microsoft YaHei UI" panose="020B0503020204020204" pitchFamily="34" charset="-122"/>
-                <a:ea typeface="Microsoft YaHei UI" panose="020B0503020204020204" pitchFamily="34" charset="-122"/>
-              </a:rPr>
-              <a:t>GnG </a:t>
-            </a:r>
-            <a:r>
-              <a:rPr lang="zh-CN" altLang="en-US" sz="1000">
-                <a:solidFill>
-                  <a:srgbClr val="64707A"/>
-                </a:solidFill>
-                <a:latin typeface="Microsoft YaHei UI" panose="020B0503020204020204" pitchFamily="34" charset="-122"/>
-                <a:ea typeface="Microsoft YaHei UI" panose="020B0503020204020204" pitchFamily="34" charset="-122"/>
-              </a:rPr>
-              <a:t>味道。</a:t>
-            </a:r>
-          </a:p>
-        </p:txBody>
-      </p:sp>
-      <p:sp>
-        <p:nvSpPr>
-          <p:cNvPr id="67" name="矩形: 圆角 66">
-            <a:extLst>
-              <a:ext uri="{FF2B5EF4-FFF2-40B4-BE49-F238E27FC236}">
-                <a16:creationId xmlns:a16="http://schemas.microsoft.com/office/drawing/2014/main" id="{50CA8EF2-BAD7-8AA5-B2DF-2A261ACC5CD8}"/>
-              </a:ext>
-            </a:extLst>
-          </p:cNvPr>
-          <p:cNvSpPr/>
-          <p:nvPr/>
-        </p:nvSpPr>
-        <p:spPr>
-          <a:xfrm>
-            <a:off x="609600" y="1981200"/>
-            <a:ext cx="5181600" cy="3276600"/>
-          </a:xfrm>
-          <a:prstGeom prst="roundRect">
-            <a:avLst>
-              <a:gd name="adj" fmla="val 12000"/>
-            </a:avLst>
-          </a:prstGeom>
           <a:solidFill>
-            <a:srgbClr val="FFFFFF"/>
+            <a:srgbClr val="1DAE9C"/>
           </a:solidFill>
-          <a:ln w="12700">
-            <a:solidFill>
-              <a:srgbClr val="DED3C5"/>
-            </a:solidFill>
+          <a:ln w="19050" cap="flat" cmpd="sng" algn="ctr">
+            <a:noFill/>
+            <a:prstDash val="solid"/>
+            <a:miter lim="800000"/>
           </a:ln>
+          <a:effectLst/>
+          <a:extLst>
+            <a:ext uri="{91240B29-F687-4F45-9708-019B960494DF}">
+              <a14:hiddenLine xmlns:a14="http://schemas.microsoft.com/office/drawing/2010/main" w="19050" cap="flat" cmpd="sng" algn="ctr">
+                <a:solidFill>
+                  <a:schemeClr val="accent1">
+                    <a:shade val="15000"/>
+                  </a:schemeClr>
+                </a:solidFill>
+                <a:prstDash val="solid"/>
+                <a:miter lim="800000"/>
+              </a14:hiddenLine>
+            </a:ext>
+          </a:extLst>
         </p:spPr>
         <p:style>
           <a:lnRef idx="2">
@@ -5699,10 +5487,10 @@
       </p:sp>
       <p:sp>
         <p:nvSpPr>
-          <p:cNvPr id="68" name="矩形 67">
-            <a:extLst>
-              <a:ext uri="{FF2B5EF4-FFF2-40B4-BE49-F238E27FC236}">
-                <a16:creationId xmlns:a16="http://schemas.microsoft.com/office/drawing/2014/main" id="{3CB5B3B4-EA3C-CF43-1F5B-AA09EED0D1B8}"/>
+          <p:cNvPr id="61" name="矩形: 圆角 60">
+            <a:extLst>
+              <a:ext uri="{FF2B5EF4-FFF2-40B4-BE49-F238E27FC236}">
+                <a16:creationId xmlns:a16="http://schemas.microsoft.com/office/drawing/2014/main" id="{DDA9EA62-5A4B-87AF-3DC0-AF953A97DFA3}"/>
               </a:ext>
             </a:extLst>
           </p:cNvPr>
@@ -5711,76 +5499,8 @@
         </p:nvSpPr>
         <p:spPr>
           <a:xfrm>
-            <a:off x="609600" y="1981200"/>
-            <a:ext cx="88900" cy="3276600"/>
-          </a:xfrm>
-          <a:prstGeom prst="rect">
-            <a:avLst/>
-          </a:prstGeom>
-          <a:solidFill>
-            <a:srgbClr val="1DAE9C"/>
-          </a:solidFill>
-          <a:ln w="19050" cap="flat" cmpd="sng" algn="ctr">
-            <a:noFill/>
-            <a:prstDash val="solid"/>
-            <a:miter lim="800000"/>
-          </a:ln>
-          <a:effectLst/>
-          <a:extLst>
-            <a:ext uri="{91240B29-F687-4F45-9708-019B960494DF}">
-              <a14:hiddenLine xmlns:a14="http://schemas.microsoft.com/office/drawing/2010/main" w="19050" cap="flat" cmpd="sng" algn="ctr">
-                <a:solidFill>
-                  <a:schemeClr val="accent1">
-                    <a:shade val="15000"/>
-                  </a:schemeClr>
-                </a:solidFill>
-                <a:prstDash val="solid"/>
-                <a:miter lim="800000"/>
-              </a14:hiddenLine>
-            </a:ext>
-          </a:extLst>
-        </p:spPr>
-        <p:style>
-          <a:lnRef idx="2">
-            <a:schemeClr val="accent1">
-              <a:shade val="15000"/>
-            </a:schemeClr>
-          </a:lnRef>
-          <a:fillRef idx="1">
-            <a:schemeClr val="accent1"/>
-          </a:fillRef>
-          <a:effectRef idx="0">
-            <a:schemeClr val="accent1"/>
-          </a:effectRef>
-          <a:fontRef idx="minor">
-            <a:schemeClr val="lt1"/>
-          </a:fontRef>
-        </p:style>
-        <p:txBody>
-          <a:bodyPr rtlCol="0" anchor="ctr"/>
-          <a:lstStyle/>
-          <a:p>
-            <a:pPr algn="ctr"/>
-            <a:endParaRPr lang="zh-CN" altLang="en-US"/>
-          </a:p>
-        </p:txBody>
-      </p:sp>
-      <p:sp>
-        <p:nvSpPr>
-          <p:cNvPr id="69" name="矩形: 圆角 68">
-            <a:extLst>
-              <a:ext uri="{FF2B5EF4-FFF2-40B4-BE49-F238E27FC236}">
-                <a16:creationId xmlns:a16="http://schemas.microsoft.com/office/drawing/2014/main" id="{83EC0AA1-9275-B2FD-6E31-CB61BF3F93AD}"/>
-              </a:ext>
-            </a:extLst>
-          </p:cNvPr>
-          <p:cNvSpPr/>
-          <p:nvPr/>
-        </p:nvSpPr>
-        <p:spPr>
-          <a:xfrm>
-            <a:off x="889000" y="2209800"/>
-            <a:ext cx="1092200" cy="254000"/>
+            <a:off x="1143000" y="2362200"/>
+            <a:ext cx="1092200" cy="279400"/>
           </a:xfrm>
           <a:prstGeom prst="roundRect">
             <a:avLst>
@@ -5837,10 +5557,10 @@
       </p:sp>
       <p:sp>
         <p:nvSpPr>
-          <p:cNvPr id="70" name="文本框 69">
-            <a:extLst>
-              <a:ext uri="{FF2B5EF4-FFF2-40B4-BE49-F238E27FC236}">
-                <a16:creationId xmlns:a16="http://schemas.microsoft.com/office/drawing/2014/main" id="{D43690EB-232B-5B86-0621-5F96CCBC3DE4}"/>
+          <p:cNvPr id="62" name="文本框 61">
+            <a:extLst>
+              <a:ext uri="{FF2B5EF4-FFF2-40B4-BE49-F238E27FC236}">
+                <a16:creationId xmlns:a16="http://schemas.microsoft.com/office/drawing/2014/main" id="{8ACCCBC5-DA93-4969-80AD-DE0454D8707F}"/>
               </a:ext>
             </a:extLst>
           </p:cNvPr>
@@ -5849,8 +5569,8 @@
         </p:nvSpPr>
         <p:spPr>
           <a:xfrm>
-            <a:off x="990600" y="2260600"/>
-            <a:ext cx="889000" cy="130805"/>
+            <a:off x="1244600" y="2385292"/>
+            <a:ext cx="889000" cy="246221"/>
           </a:xfrm>
           <a:prstGeom prst="rect">
             <a:avLst/>
@@ -5865,9 +5585,9 @@
           <a:p>
             <a:pPr algn="ctr"/>
             <a:r>
-              <a:rPr lang="zh-CN" altLang="en-US" sz="850" b="1">
-                <a:solidFill>
-                  <a:srgbClr val="FFFFFF"/>
+              <a:rPr lang="zh-CN" altLang="en-US" sz="1600" b="1" dirty="0">
+                <a:solidFill>
+                  <a:srgbClr val="F8F6EF"/>
                 </a:solidFill>
                 <a:latin typeface="Microsoft YaHei UI" panose="020B0503020204020204" pitchFamily="34" charset="-122"/>
                 <a:ea typeface="Microsoft YaHei UI" panose="020B0503020204020204" pitchFamily="34" charset="-122"/>
@@ -5879,10 +5599,10 @@
       </p:sp>
       <p:sp>
         <p:nvSpPr>
-          <p:cNvPr id="71" name="文本框 70">
-            <a:extLst>
-              <a:ext uri="{FF2B5EF4-FFF2-40B4-BE49-F238E27FC236}">
-                <a16:creationId xmlns:a16="http://schemas.microsoft.com/office/drawing/2014/main" id="{A50C4076-65BE-FC1F-C050-E55E75F8C279}"/>
+          <p:cNvPr id="63" name="文本框 62">
+            <a:extLst>
+              <a:ext uri="{FF2B5EF4-FFF2-40B4-BE49-F238E27FC236}">
+                <a16:creationId xmlns:a16="http://schemas.microsoft.com/office/drawing/2014/main" id="{06E43C50-30CD-1DBF-8632-ED7CBF3492C6}"/>
               </a:ext>
             </a:extLst>
           </p:cNvPr>
@@ -5891,8 +5611,8 @@
         </p:nvSpPr>
         <p:spPr>
           <a:xfrm>
-            <a:off x="889000" y="2578100"/>
-            <a:ext cx="4622800" cy="292388"/>
+            <a:off x="965200" y="2895600"/>
+            <a:ext cx="4470400" cy="292388"/>
           </a:xfrm>
           <a:prstGeom prst="rect">
             <a:avLst/>
@@ -5906,65 +5626,24 @@
           <a:lstStyle/>
           <a:p>
             <a:r>
-              <a:rPr lang="zh-CN" altLang="en-US" sz="1900" b="1">
-                <a:solidFill>
-                  <a:srgbClr val="1E252C"/>
+              <a:rPr lang="zh-CN" altLang="en-US" sz="1900" b="1" dirty="0">
+                <a:solidFill>
+                  <a:srgbClr val="F8F6EF"/>
                 </a:solidFill>
                 <a:latin typeface="Microsoft YaHei UI" panose="020B0503020204020204" pitchFamily="34" charset="-122"/>
                 <a:ea typeface="Microsoft YaHei UI" panose="020B0503020204020204" pitchFamily="34" charset="-122"/>
               </a:rPr>
-              <a:t>新玩家：愿意尝试，但卡在理解和操作</a:t>
-            </a:r>
-          </a:p>
-        </p:txBody>
-      </p:sp>
-      <p:sp>
-        <p:nvSpPr>
-          <p:cNvPr id="72" name="文本框 71">
-            <a:extLst>
-              <a:ext uri="{FF2B5EF4-FFF2-40B4-BE49-F238E27FC236}">
-                <a16:creationId xmlns:a16="http://schemas.microsoft.com/office/drawing/2014/main" id="{2659C929-9676-9B55-886A-55BCB380632D}"/>
-              </a:ext>
-            </a:extLst>
-          </p:cNvPr>
-          <p:cNvSpPr txBox="1"/>
-          <p:nvPr/>
-        </p:nvSpPr>
-        <p:spPr>
-          <a:xfrm>
-            <a:off x="889000" y="2933700"/>
-            <a:ext cx="4622800" cy="161583"/>
-          </a:xfrm>
-          <a:prstGeom prst="rect">
-            <a:avLst/>
-          </a:prstGeom>
-          <a:noFill/>
-        </p:spPr>
-        <p:txBody>
-          <a:bodyPr vert="horz" wrap="square" lIns="0" tIns="0" rIns="0" bIns="0" rtlCol="0">
-            <a:spAutoFit/>
-          </a:bodyPr>
-          <a:lstStyle/>
-          <a:p>
-            <a:r>
-              <a:rPr lang="zh-CN" altLang="en-US" sz="1050">
-                <a:solidFill>
-                  <a:srgbClr val="64707A"/>
-                </a:solidFill>
-                <a:latin typeface="Microsoft YaHei UI" panose="020B0503020204020204" pitchFamily="34" charset="-122"/>
-                <a:ea typeface="Microsoft YaHei UI" panose="020B0503020204020204" pitchFamily="34" charset="-122"/>
-              </a:rPr>
-              <a:t>被题材和团队战吸引，进入门槛主要来自操作与信息理解。</a:t>
-            </a:r>
-          </a:p>
-        </p:txBody>
-      </p:sp>
-      <p:sp>
-        <p:nvSpPr>
-          <p:cNvPr id="73" name="矩形: 圆角 72">
-            <a:extLst>
-              <a:ext uri="{FF2B5EF4-FFF2-40B4-BE49-F238E27FC236}">
-                <a16:creationId xmlns:a16="http://schemas.microsoft.com/office/drawing/2014/main" id="{19811B9E-98CF-631F-4E8E-64AA582CA7D3}"/>
+              <a:t>愿意尝试，进入门槛主要来自信息理解</a:t>
+            </a:r>
+          </a:p>
+        </p:txBody>
+      </p:sp>
+      <p:sp>
+        <p:nvSpPr>
+          <p:cNvPr id="64" name="矩形: 圆角 63">
+            <a:extLst>
+              <a:ext uri="{FF2B5EF4-FFF2-40B4-BE49-F238E27FC236}">
+                <a16:creationId xmlns:a16="http://schemas.microsoft.com/office/drawing/2014/main" id="{6BA477CF-D23E-115D-C4E3-67DFD9B51525}"/>
               </a:ext>
             </a:extLst>
           </p:cNvPr>
@@ -5973,16 +5652,16 @@
         </p:nvSpPr>
         <p:spPr>
           <a:xfrm>
-            <a:off x="889000" y="3302000"/>
-            <a:ext cx="4622800" cy="787400"/>
+            <a:off x="955964" y="3417451"/>
+            <a:ext cx="4470400" cy="812800"/>
           </a:xfrm>
           <a:prstGeom prst="roundRect">
             <a:avLst>
-              <a:gd name="adj" fmla="val 12000"/>
+              <a:gd name="adj" fmla="val 10000"/>
             </a:avLst>
           </a:prstGeom>
           <a:solidFill>
-            <a:srgbClr val="EAF7F5"/>
+            <a:srgbClr val="162A2D"/>
           </a:solidFill>
           <a:ln w="19050" cap="flat" cmpd="sng" algn="ctr">
             <a:noFill/>
@@ -6031,10 +5710,10 @@
       </p:sp>
       <p:sp>
         <p:nvSpPr>
-          <p:cNvPr id="74" name="文本框 73">
-            <a:extLst>
-              <a:ext uri="{FF2B5EF4-FFF2-40B4-BE49-F238E27FC236}">
-                <a16:creationId xmlns:a16="http://schemas.microsoft.com/office/drawing/2014/main" id="{55724EA3-4F93-C26B-E4C5-8D4634ACFA4B}"/>
+          <p:cNvPr id="65" name="文本框 64">
+            <a:extLst>
+              <a:ext uri="{FF2B5EF4-FFF2-40B4-BE49-F238E27FC236}">
+                <a16:creationId xmlns:a16="http://schemas.microsoft.com/office/drawing/2014/main" id="{0493D3AF-653A-2BB6-9953-BB10B4AC0E5F}"/>
               </a:ext>
             </a:extLst>
           </p:cNvPr>
@@ -6043,8 +5722,8 @@
         </p:nvSpPr>
         <p:spPr>
           <a:xfrm>
-            <a:off x="1066800" y="3429000"/>
-            <a:ext cx="698500" cy="176972"/>
+            <a:off x="1133764" y="3452091"/>
+            <a:ext cx="1206500" cy="184666"/>
           </a:xfrm>
           <a:prstGeom prst="rect">
             <a:avLst/>
@@ -6058,7 +5737,7 @@
           <a:lstStyle/>
           <a:p>
             <a:r>
-              <a:rPr lang="zh-CN" altLang="en-US" sz="1150" b="1">
+              <a:rPr lang="zh-CN" altLang="en-US" sz="1200" b="1" dirty="0">
                 <a:solidFill>
                   <a:srgbClr val="1DAE9C"/>
                 </a:solidFill>
@@ -6072,10 +5751,10 @@
       </p:sp>
       <p:sp>
         <p:nvSpPr>
-          <p:cNvPr id="75" name="椭圆 74">
-            <a:extLst>
-              <a:ext uri="{FF2B5EF4-FFF2-40B4-BE49-F238E27FC236}">
-                <a16:creationId xmlns:a16="http://schemas.microsoft.com/office/drawing/2014/main" id="{71CEC486-B374-05AF-313D-36C7EBF1D0CC}"/>
+          <p:cNvPr id="66" name="椭圆 65">
+            <a:extLst>
+              <a:ext uri="{FF2B5EF4-FFF2-40B4-BE49-F238E27FC236}">
+                <a16:creationId xmlns:a16="http://schemas.microsoft.com/office/drawing/2014/main" id="{BAC7B936-F111-276C-B15C-208D51A7B013}"/>
               </a:ext>
             </a:extLst>
           </p:cNvPr>
@@ -6084,7 +5763,7 @@
         </p:nvSpPr>
         <p:spPr>
           <a:xfrm>
-            <a:off x="1066800" y="3733800"/>
+            <a:off x="1133764" y="3769591"/>
             <a:ext cx="139700" cy="139700"/>
           </a:xfrm>
           <a:prstGeom prst="ellipse">
@@ -6156,10 +5835,10 @@
       </p:sp>
       <p:sp>
         <p:nvSpPr>
-          <p:cNvPr id="76" name="文本框 75">
-            <a:extLst>
-              <a:ext uri="{FF2B5EF4-FFF2-40B4-BE49-F238E27FC236}">
-                <a16:creationId xmlns:a16="http://schemas.microsoft.com/office/drawing/2014/main" id="{45A18F24-895D-C219-45AA-FB9B149E7E63}"/>
+          <p:cNvPr id="67" name="文本框 66">
+            <a:extLst>
+              <a:ext uri="{FF2B5EF4-FFF2-40B4-BE49-F238E27FC236}">
+                <a16:creationId xmlns:a16="http://schemas.microsoft.com/office/drawing/2014/main" id="{7B66304E-0817-862F-E0AA-53E709E92A3E}"/>
               </a:ext>
             </a:extLst>
           </p:cNvPr>
@@ -6168,8 +5847,8 @@
         </p:nvSpPr>
         <p:spPr>
           <a:xfrm>
-            <a:off x="1282700" y="3721100"/>
-            <a:ext cx="4318000" cy="161583"/>
+            <a:off x="1362364" y="3744191"/>
+            <a:ext cx="4191000" cy="184666"/>
           </a:xfrm>
           <a:prstGeom prst="rect">
             <a:avLst/>
@@ -6183,9 +5862,9 @@
           <a:lstStyle/>
           <a:p>
             <a:r>
-              <a:rPr lang="zh-CN" altLang="en-US" sz="1050">
-                <a:solidFill>
-                  <a:srgbClr val="26313A"/>
+              <a:rPr lang="zh-CN" altLang="en-US" sz="1200" dirty="0">
+                <a:solidFill>
+                  <a:srgbClr val="D8E0E6"/>
                 </a:solidFill>
                 <a:latin typeface="Microsoft YaHei UI" panose="020B0503020204020204" pitchFamily="34" charset="-122"/>
                 <a:ea typeface="Microsoft YaHei UI" panose="020B0503020204020204" pitchFamily="34" charset="-122"/>
@@ -6197,10 +5876,10 @@
       </p:sp>
       <p:sp>
         <p:nvSpPr>
-          <p:cNvPr id="77" name="椭圆 76">
-            <a:extLst>
-              <a:ext uri="{FF2B5EF4-FFF2-40B4-BE49-F238E27FC236}">
-                <a16:creationId xmlns:a16="http://schemas.microsoft.com/office/drawing/2014/main" id="{BFF8146C-52B1-085D-59A1-2D67A1BB9356}"/>
+          <p:cNvPr id="68" name="椭圆 67">
+            <a:extLst>
+              <a:ext uri="{FF2B5EF4-FFF2-40B4-BE49-F238E27FC236}">
+                <a16:creationId xmlns:a16="http://schemas.microsoft.com/office/drawing/2014/main" id="{F84DCD1C-C1C4-55AB-27B1-3F5A99B050AA}"/>
               </a:ext>
             </a:extLst>
           </p:cNvPr>
@@ -6209,7 +5888,7 @@
         </p:nvSpPr>
         <p:spPr>
           <a:xfrm>
-            <a:off x="1066800" y="4013200"/>
+            <a:off x="1133764" y="4048991"/>
             <a:ext cx="139700" cy="139700"/>
           </a:xfrm>
           <a:prstGeom prst="ellipse">
@@ -6281,10 +5960,10 @@
       </p:sp>
       <p:sp>
         <p:nvSpPr>
-          <p:cNvPr id="78" name="文本框 77">
-            <a:extLst>
-              <a:ext uri="{FF2B5EF4-FFF2-40B4-BE49-F238E27FC236}">
-                <a16:creationId xmlns:a16="http://schemas.microsoft.com/office/drawing/2014/main" id="{BEE4E09B-8D35-7CE8-459D-F5ADB4BE2DFD}"/>
+          <p:cNvPr id="69" name="文本框 68">
+            <a:extLst>
+              <a:ext uri="{FF2B5EF4-FFF2-40B4-BE49-F238E27FC236}">
+                <a16:creationId xmlns:a16="http://schemas.microsoft.com/office/drawing/2014/main" id="{90FF0170-6168-946C-B2E9-B8EAAA293D8B}"/>
               </a:ext>
             </a:extLst>
           </p:cNvPr>
@@ -6293,8 +5972,8 @@
         </p:nvSpPr>
         <p:spPr>
           <a:xfrm>
-            <a:off x="1282700" y="4000500"/>
-            <a:ext cx="4318000" cy="161583"/>
+            <a:off x="1362364" y="4023591"/>
+            <a:ext cx="4191000" cy="184666"/>
           </a:xfrm>
           <a:prstGeom prst="rect">
             <a:avLst/>
@@ -6308,9 +5987,9 @@
           <a:lstStyle/>
           <a:p>
             <a:r>
-              <a:rPr lang="en-US" altLang="zh-CN" sz="1050">
-                <a:solidFill>
-                  <a:srgbClr val="26313A"/>
+              <a:rPr lang="en-US" altLang="zh-CN" sz="1200">
+                <a:solidFill>
+                  <a:srgbClr val="D8E0E6"/>
                 </a:solidFill>
                 <a:latin typeface="Microsoft YaHei UI" panose="020B0503020204020204" pitchFamily="34" charset="-122"/>
                 <a:ea typeface="Microsoft YaHei UI" panose="020B0503020204020204" pitchFamily="34" charset="-122"/>
@@ -6318,9 +5997,9 @@
               <a:t>3v3 </a:t>
             </a:r>
             <a:r>
-              <a:rPr lang="zh-CN" altLang="en-US" sz="1050">
-                <a:solidFill>
-                  <a:srgbClr val="26313A"/>
+              <a:rPr lang="zh-CN" altLang="en-US" sz="1200">
+                <a:solidFill>
+                  <a:srgbClr val="D8E0E6"/>
                 </a:solidFill>
                 <a:latin typeface="Microsoft YaHei UI" panose="020B0503020204020204" pitchFamily="34" charset="-122"/>
                 <a:ea typeface="Microsoft YaHei UI" panose="020B0503020204020204" pitchFamily="34" charset="-122"/>
@@ -6332,10 +6011,10 @@
       </p:sp>
       <p:sp>
         <p:nvSpPr>
-          <p:cNvPr id="79" name="矩形: 圆角 78">
-            <a:extLst>
-              <a:ext uri="{FF2B5EF4-FFF2-40B4-BE49-F238E27FC236}">
-                <a16:creationId xmlns:a16="http://schemas.microsoft.com/office/drawing/2014/main" id="{E2904E8E-8F16-BBAF-BC7D-5A35F11A4910}"/>
+          <p:cNvPr id="70" name="矩形: 圆角 69">
+            <a:extLst>
+              <a:ext uri="{FF2B5EF4-FFF2-40B4-BE49-F238E27FC236}">
+                <a16:creationId xmlns:a16="http://schemas.microsoft.com/office/drawing/2014/main" id="{05A5E449-3ED8-B9E0-59C6-23D11FB63F49}"/>
               </a:ext>
             </a:extLst>
           </p:cNvPr>
@@ -6344,16 +6023,16 @@
         </p:nvSpPr>
         <p:spPr>
           <a:xfrm>
-            <a:off x="889000" y="4216400"/>
-            <a:ext cx="4622800" cy="914400"/>
+            <a:off x="955964" y="4518887"/>
+            <a:ext cx="4470400" cy="1226070"/>
           </a:xfrm>
           <a:prstGeom prst="roundRect">
             <a:avLst>
-              <a:gd name="adj" fmla="val 12000"/>
+              <a:gd name="adj" fmla="val 10000"/>
             </a:avLst>
           </a:prstGeom>
           <a:solidFill>
-            <a:srgbClr val="FFF7F2"/>
+            <a:srgbClr val="221A18"/>
           </a:solidFill>
           <a:ln w="19050" cap="flat" cmpd="sng" algn="ctr">
             <a:noFill/>
@@ -6402,10 +6081,10 @@
       </p:sp>
       <p:sp>
         <p:nvSpPr>
-          <p:cNvPr id="80" name="文本框 79">
-            <a:extLst>
-              <a:ext uri="{FF2B5EF4-FFF2-40B4-BE49-F238E27FC236}">
-                <a16:creationId xmlns:a16="http://schemas.microsoft.com/office/drawing/2014/main" id="{BF3833F2-B38E-CEDD-B087-6779E5C2F034}"/>
+          <p:cNvPr id="71" name="文本框 70">
+            <a:extLst>
+              <a:ext uri="{FF2B5EF4-FFF2-40B4-BE49-F238E27FC236}">
+                <a16:creationId xmlns:a16="http://schemas.microsoft.com/office/drawing/2014/main" id="{1D613533-4130-E248-FEB0-D0C33DD46D61}"/>
               </a:ext>
             </a:extLst>
           </p:cNvPr>
@@ -6414,8 +6093,8 @@
         </p:nvSpPr>
         <p:spPr>
           <a:xfrm>
-            <a:off x="1066800" y="4330700"/>
-            <a:ext cx="1206500" cy="176972"/>
+            <a:off x="1133764" y="4544291"/>
+            <a:ext cx="1206500" cy="184666"/>
           </a:xfrm>
           <a:prstGeom prst="rect">
             <a:avLst/>
@@ -6429,9 +6108,9 @@
           <a:lstStyle/>
           <a:p>
             <a:r>
-              <a:rPr lang="zh-CN" altLang="en-US" sz="1150" b="1">
-                <a:solidFill>
-                  <a:srgbClr val="D65A3A"/>
+              <a:rPr lang="zh-CN" altLang="en-US" sz="1200" b="1">
+                <a:solidFill>
+                  <a:srgbClr val="FF6B52"/>
                 </a:solidFill>
                 <a:latin typeface="Microsoft YaHei UI" panose="020B0503020204020204" pitchFamily="34" charset="-122"/>
                 <a:ea typeface="Microsoft YaHei UI" panose="020B0503020204020204" pitchFamily="34" charset="-122"/>
@@ -6439,9 +6118,9 @@
               <a:t>阻碍 </a:t>
             </a:r>
             <a:r>
-              <a:rPr lang="en-US" altLang="zh-CN" sz="1150" b="1">
-                <a:solidFill>
-                  <a:srgbClr val="D65A3A"/>
+              <a:rPr lang="en-US" altLang="zh-CN" sz="1200" b="1">
+                <a:solidFill>
+                  <a:srgbClr val="FF6B52"/>
                 </a:solidFill>
                 <a:latin typeface="Microsoft YaHei UI" panose="020B0503020204020204" pitchFamily="34" charset="-122"/>
                 <a:ea typeface="Microsoft YaHei UI" panose="020B0503020204020204" pitchFamily="34" charset="-122"/>
@@ -6449,9 +6128,9 @@
               <a:t>/ </a:t>
             </a:r>
             <a:r>
-              <a:rPr lang="zh-CN" altLang="en-US" sz="1150" b="1">
-                <a:solidFill>
-                  <a:srgbClr val="D65A3A"/>
+              <a:rPr lang="zh-CN" altLang="en-US" sz="1200" b="1">
+                <a:solidFill>
+                  <a:srgbClr val="FF6B52"/>
                 </a:solidFill>
                 <a:latin typeface="Microsoft YaHei UI" panose="020B0503020204020204" pitchFamily="34" charset="-122"/>
                 <a:ea typeface="Microsoft YaHei UI" panose="020B0503020204020204" pitchFamily="34" charset="-122"/>
@@ -6463,10 +6142,10 @@
       </p:sp>
       <p:sp>
         <p:nvSpPr>
-          <p:cNvPr id="81" name="椭圆 80">
-            <a:extLst>
-              <a:ext uri="{FF2B5EF4-FFF2-40B4-BE49-F238E27FC236}">
-                <a16:creationId xmlns:a16="http://schemas.microsoft.com/office/drawing/2014/main" id="{5019710D-7225-945D-1FAE-6DA43236EA5B}"/>
+          <p:cNvPr id="72" name="椭圆 71">
+            <a:extLst>
+              <a:ext uri="{FF2B5EF4-FFF2-40B4-BE49-F238E27FC236}">
+                <a16:creationId xmlns:a16="http://schemas.microsoft.com/office/drawing/2014/main" id="{3357C96E-A41B-F1C1-A456-DBDA17CFC686}"/>
               </a:ext>
             </a:extLst>
           </p:cNvPr>
@@ -6475,14 +6154,14 @@
         </p:nvSpPr>
         <p:spPr>
           <a:xfrm>
-            <a:off x="1066800" y="4622800"/>
+            <a:off x="1133764" y="4861791"/>
             <a:ext cx="139700" cy="139700"/>
           </a:xfrm>
           <a:prstGeom prst="ellipse">
             <a:avLst/>
           </a:prstGeom>
           <a:solidFill>
-            <a:srgbClr val="D65A3A"/>
+            <a:srgbClr val="FF6B52"/>
           </a:solidFill>
           <a:ln w="19050" cap="flat" cmpd="sng" algn="ctr">
             <a:noFill/>
@@ -6547,10 +6226,10 @@
       </p:sp>
       <p:sp>
         <p:nvSpPr>
-          <p:cNvPr id="82" name="文本框 81">
-            <a:extLst>
-              <a:ext uri="{FF2B5EF4-FFF2-40B4-BE49-F238E27FC236}">
-                <a16:creationId xmlns:a16="http://schemas.microsoft.com/office/drawing/2014/main" id="{EAB949F0-6485-3C8B-6F0B-34CBEFDA80F5}"/>
+          <p:cNvPr id="73" name="文本框 72">
+            <a:extLst>
+              <a:ext uri="{FF2B5EF4-FFF2-40B4-BE49-F238E27FC236}">
+                <a16:creationId xmlns:a16="http://schemas.microsoft.com/office/drawing/2014/main" id="{C502EE11-9890-6BCA-84AC-F9C21EE33BA1}"/>
               </a:ext>
             </a:extLst>
           </p:cNvPr>
@@ -6559,8 +6238,8 @@
         </p:nvSpPr>
         <p:spPr>
           <a:xfrm>
-            <a:off x="1282700" y="4610100"/>
-            <a:ext cx="4318000" cy="161583"/>
+            <a:off x="1362364" y="4836391"/>
+            <a:ext cx="4191000" cy="184666"/>
           </a:xfrm>
           <a:prstGeom prst="rect">
             <a:avLst/>
@@ -6574,9 +6253,9 @@
           <a:lstStyle/>
           <a:p>
             <a:r>
-              <a:rPr lang="zh-CN" altLang="en-US" sz="1050">
-                <a:solidFill>
-                  <a:srgbClr val="26313A"/>
+              <a:rPr lang="zh-CN" altLang="en-US" sz="1200">
+                <a:solidFill>
+                  <a:srgbClr val="D8E0E6"/>
                 </a:solidFill>
                 <a:latin typeface="Microsoft YaHei UI" panose="020B0503020204020204" pitchFamily="34" charset="-122"/>
                 <a:ea typeface="Microsoft YaHei UI" panose="020B0503020204020204" pitchFamily="34" charset="-122"/>
@@ -6584,9 +6263,9 @@
               <a:t>按钮小 </a:t>
             </a:r>
             <a:r>
-              <a:rPr lang="en-US" altLang="zh-CN" sz="1050">
-                <a:solidFill>
-                  <a:srgbClr val="26313A"/>
+              <a:rPr lang="en-US" altLang="zh-CN" sz="1200">
+                <a:solidFill>
+                  <a:srgbClr val="D8E0E6"/>
                 </a:solidFill>
                 <a:latin typeface="Microsoft YaHei UI" panose="020B0503020204020204" pitchFamily="34" charset="-122"/>
                 <a:ea typeface="Microsoft YaHei UI" panose="020B0503020204020204" pitchFamily="34" charset="-122"/>
@@ -6594,9 +6273,9 @@
               <a:t>/ </a:t>
             </a:r>
             <a:r>
-              <a:rPr lang="zh-CN" altLang="en-US" sz="1050">
-                <a:solidFill>
-                  <a:srgbClr val="26313A"/>
+              <a:rPr lang="zh-CN" altLang="en-US" sz="1200">
+                <a:solidFill>
+                  <a:srgbClr val="D8E0E6"/>
                 </a:solidFill>
                 <a:latin typeface="Microsoft YaHei UI" panose="020B0503020204020204" pitchFamily="34" charset="-122"/>
                 <a:ea typeface="Microsoft YaHei UI" panose="020B0503020204020204" pitchFamily="34" charset="-122"/>
@@ -6608,10 +6287,10 @@
       </p:sp>
       <p:sp>
         <p:nvSpPr>
-          <p:cNvPr id="83" name="椭圆 82">
-            <a:extLst>
-              <a:ext uri="{FF2B5EF4-FFF2-40B4-BE49-F238E27FC236}">
-                <a16:creationId xmlns:a16="http://schemas.microsoft.com/office/drawing/2014/main" id="{02ED7045-FD2A-00EF-C2D0-3798CBD21A89}"/>
+          <p:cNvPr id="74" name="椭圆 73">
+            <a:extLst>
+              <a:ext uri="{FF2B5EF4-FFF2-40B4-BE49-F238E27FC236}">
+                <a16:creationId xmlns:a16="http://schemas.microsoft.com/office/drawing/2014/main" id="{AC32B1B8-37DE-7B36-99BE-CDAD12CEC826}"/>
               </a:ext>
             </a:extLst>
           </p:cNvPr>
@@ -6620,14 +6299,14 @@
         </p:nvSpPr>
         <p:spPr>
           <a:xfrm>
-            <a:off x="1066800" y="4864100"/>
+            <a:off x="1133764" y="5141191"/>
             <a:ext cx="139700" cy="139700"/>
           </a:xfrm>
           <a:prstGeom prst="ellipse">
             <a:avLst/>
           </a:prstGeom>
           <a:solidFill>
-            <a:srgbClr val="D65A3A"/>
+            <a:srgbClr val="FF6B52"/>
           </a:solidFill>
           <a:ln w="19050" cap="flat" cmpd="sng" algn="ctr">
             <a:noFill/>
@@ -6692,10 +6371,10 @@
       </p:sp>
       <p:sp>
         <p:nvSpPr>
-          <p:cNvPr id="84" name="文本框 83">
-            <a:extLst>
-              <a:ext uri="{FF2B5EF4-FFF2-40B4-BE49-F238E27FC236}">
-                <a16:creationId xmlns:a16="http://schemas.microsoft.com/office/drawing/2014/main" id="{901026C1-B5A7-4C1C-9781-E75B2F58532E}"/>
+          <p:cNvPr id="75" name="文本框 74">
+            <a:extLst>
+              <a:ext uri="{FF2B5EF4-FFF2-40B4-BE49-F238E27FC236}">
+                <a16:creationId xmlns:a16="http://schemas.microsoft.com/office/drawing/2014/main" id="{370193AD-D676-193B-CB41-E0960B7A2D59}"/>
               </a:ext>
             </a:extLst>
           </p:cNvPr>
@@ -6704,8 +6383,8 @@
         </p:nvSpPr>
         <p:spPr>
           <a:xfrm>
-            <a:off x="1282700" y="4851400"/>
-            <a:ext cx="4318000" cy="161583"/>
+            <a:off x="1362364" y="5115791"/>
+            <a:ext cx="4191000" cy="184666"/>
           </a:xfrm>
           <a:prstGeom prst="rect">
             <a:avLst/>
@@ -6719,9 +6398,9 @@
           <a:lstStyle/>
           <a:p>
             <a:r>
-              <a:rPr lang="zh-CN" altLang="en-US" sz="1050">
-                <a:solidFill>
-                  <a:srgbClr val="26313A"/>
+              <a:rPr lang="zh-CN" altLang="en-US" sz="1200">
+                <a:solidFill>
+                  <a:srgbClr val="D8E0E6"/>
                 </a:solidFill>
                 <a:latin typeface="Microsoft YaHei UI" panose="020B0503020204020204" pitchFamily="34" charset="-122"/>
                 <a:ea typeface="Microsoft YaHei UI" panose="020B0503020204020204" pitchFamily="34" charset="-122"/>
@@ -6729,9 +6408,9 @@
               <a:t>信息看不懂，</a:t>
             </a:r>
             <a:r>
-              <a:rPr lang="en-US" altLang="zh-CN" sz="1050">
-                <a:solidFill>
-                  <a:srgbClr val="26313A"/>
+              <a:rPr lang="en-US" altLang="zh-CN" sz="1200">
+                <a:solidFill>
+                  <a:srgbClr val="D8E0E6"/>
                 </a:solidFill>
                 <a:latin typeface="Microsoft YaHei UI" panose="020B0503020204020204" pitchFamily="34" charset="-122"/>
                 <a:ea typeface="Microsoft YaHei UI" panose="020B0503020204020204" pitchFamily="34" charset="-122"/>
@@ -6739,9 +6418,9 @@
               <a:t>PvE </a:t>
             </a:r>
             <a:r>
-              <a:rPr lang="zh-CN" altLang="en-US" sz="1050">
-                <a:solidFill>
-                  <a:srgbClr val="26313A"/>
+              <a:rPr lang="zh-CN" altLang="en-US" sz="1200">
+                <a:solidFill>
+                  <a:srgbClr val="D8E0E6"/>
                 </a:solidFill>
                 <a:latin typeface="Microsoft YaHei UI" panose="020B0503020204020204" pitchFamily="34" charset="-122"/>
                 <a:ea typeface="Microsoft YaHei UI" panose="020B0503020204020204" pitchFamily="34" charset="-122"/>
@@ -6753,10 +6432,10 @@
       </p:sp>
       <p:sp>
         <p:nvSpPr>
-          <p:cNvPr id="85" name="矩形: 圆角 84">
-            <a:extLst>
-              <a:ext uri="{FF2B5EF4-FFF2-40B4-BE49-F238E27FC236}">
-                <a16:creationId xmlns:a16="http://schemas.microsoft.com/office/drawing/2014/main" id="{436F2333-9D35-BBD2-D298-A6F3C86993BF}"/>
+          <p:cNvPr id="76" name="矩形: 圆角 75">
+            <a:extLst>
+              <a:ext uri="{FF2B5EF4-FFF2-40B4-BE49-F238E27FC236}">
+                <a16:creationId xmlns:a16="http://schemas.microsoft.com/office/drawing/2014/main" id="{49561FAD-4E1B-83F3-ED01-731D6D8FB529}"/>
               </a:ext>
             </a:extLst>
           </p:cNvPr>
@@ -6765,20 +6444,20 @@
         </p:nvSpPr>
         <p:spPr>
           <a:xfrm>
-            <a:off x="6400800" y="1981200"/>
-            <a:ext cx="5181600" cy="3276600"/>
+            <a:off x="6400800" y="2108200"/>
+            <a:ext cx="5181600" cy="3886200"/>
           </a:xfrm>
           <a:prstGeom prst="roundRect">
             <a:avLst>
-              <a:gd name="adj" fmla="val 12000"/>
+              <a:gd name="adj" fmla="val 10000"/>
             </a:avLst>
           </a:prstGeom>
           <a:solidFill>
-            <a:srgbClr val="FFFFFF"/>
+            <a:srgbClr val="101820"/>
           </a:solidFill>
           <a:ln w="12700">
             <a:solidFill>
-              <a:srgbClr val="DED3C5"/>
+              <a:srgbClr val="33414E"/>
             </a:solidFill>
           </a:ln>
         </p:spPr>
@@ -6809,10 +6488,10 @@
       </p:sp>
       <p:sp>
         <p:nvSpPr>
-          <p:cNvPr id="86" name="矩形 85">
-            <a:extLst>
-              <a:ext uri="{FF2B5EF4-FFF2-40B4-BE49-F238E27FC236}">
-                <a16:creationId xmlns:a16="http://schemas.microsoft.com/office/drawing/2014/main" id="{2261BC59-3311-4751-9155-CA3A9595CBC7}"/>
+          <p:cNvPr id="77" name="矩形 76">
+            <a:extLst>
+              <a:ext uri="{FF2B5EF4-FFF2-40B4-BE49-F238E27FC236}">
+                <a16:creationId xmlns:a16="http://schemas.microsoft.com/office/drawing/2014/main" id="{C40C89CB-0FBE-A843-12E9-2291C94B240D}"/>
               </a:ext>
             </a:extLst>
           </p:cNvPr>
@@ -6821,8 +6500,8 @@
         </p:nvSpPr>
         <p:spPr>
           <a:xfrm>
-            <a:off x="6400800" y="1981200"/>
-            <a:ext cx="88900" cy="3276600"/>
+            <a:off x="6400800" y="2108200"/>
+            <a:ext cx="88900" cy="3886200"/>
           </a:xfrm>
           <a:prstGeom prst="rect">
             <a:avLst/>
@@ -6877,10 +6556,10 @@
       </p:sp>
       <p:sp>
         <p:nvSpPr>
-          <p:cNvPr id="87" name="矩形: 圆角 86">
-            <a:extLst>
-              <a:ext uri="{FF2B5EF4-FFF2-40B4-BE49-F238E27FC236}">
-                <a16:creationId xmlns:a16="http://schemas.microsoft.com/office/drawing/2014/main" id="{998CCE92-9386-FEFF-0BFA-4540B906B2B5}"/>
+          <p:cNvPr id="78" name="椭圆 77">
+            <a:extLst>
+              <a:ext uri="{FF2B5EF4-FFF2-40B4-BE49-F238E27FC236}">
+                <a16:creationId xmlns:a16="http://schemas.microsoft.com/office/drawing/2014/main" id="{095C6015-CE2C-5F2E-AFEB-6DBEE0553708}"/>
               </a:ext>
             </a:extLst>
           </p:cNvPr>
@@ -6889,13 +6568,11 @@
         </p:nvSpPr>
         <p:spPr>
           <a:xfrm>
-            <a:off x="6680200" y="2209800"/>
-            <a:ext cx="1092200" cy="254000"/>
-          </a:xfrm>
-          <a:prstGeom prst="roundRect">
-            <a:avLst>
-              <a:gd name="adj" fmla="val 50000"/>
-            </a:avLst>
+            <a:off x="6654800" y="2438400"/>
+            <a:ext cx="127000" cy="127000"/>
+          </a:xfrm>
+          <a:prstGeom prst="ellipse">
+            <a:avLst/>
           </a:prstGeom>
           <a:solidFill>
             <a:srgbClr val="E26A3B"/>
@@ -6947,10 +6624,10 @@
       </p:sp>
       <p:sp>
         <p:nvSpPr>
-          <p:cNvPr id="88" name="文本框 87">
-            <a:extLst>
-              <a:ext uri="{FF2B5EF4-FFF2-40B4-BE49-F238E27FC236}">
-                <a16:creationId xmlns:a16="http://schemas.microsoft.com/office/drawing/2014/main" id="{2B14A54F-6907-D28E-B6E9-40F2C2ED7187}"/>
+          <p:cNvPr id="79" name="文本框 78">
+            <a:extLst>
+              <a:ext uri="{FF2B5EF4-FFF2-40B4-BE49-F238E27FC236}">
+                <a16:creationId xmlns:a16="http://schemas.microsoft.com/office/drawing/2014/main" id="{30DEA3EC-A58C-A88B-2B90-E44BF7348508}"/>
               </a:ext>
             </a:extLst>
           </p:cNvPr>
@@ -6959,8 +6636,8 @@
         </p:nvSpPr>
         <p:spPr>
           <a:xfrm>
-            <a:off x="6781800" y="2260600"/>
-            <a:ext cx="889000" cy="130805"/>
+            <a:off x="6756400" y="2895600"/>
+            <a:ext cx="4470400" cy="292388"/>
           </a:xfrm>
           <a:prstGeom prst="rect">
             <a:avLst/>
@@ -6973,128 +6650,25 @@
           </a:bodyPr>
           <a:lstStyle/>
           <a:p>
-            <a:pPr algn="ctr"/>
-            <a:r>
-              <a:rPr lang="zh-CN" altLang="en-US" sz="850" b="1">
-                <a:solidFill>
-                  <a:srgbClr val="FFFFFF"/>
+            <a:r>
+              <a:rPr lang="zh-CN" altLang="en-US" sz="1900" b="1" dirty="0">
+                <a:solidFill>
+                  <a:srgbClr val="F8F6EF"/>
                 </a:solidFill>
                 <a:latin typeface="Microsoft YaHei UI" panose="020B0503020204020204" pitchFamily="34" charset="-122"/>
                 <a:ea typeface="Microsoft YaHei UI" panose="020B0503020204020204" pitchFamily="34" charset="-122"/>
               </a:rPr>
-              <a:t>老玩家</a:t>
-            </a:r>
-          </a:p>
-        </p:txBody>
-      </p:sp>
-      <p:sp>
-        <p:nvSpPr>
-          <p:cNvPr id="89" name="文本框 88">
-            <a:extLst>
-              <a:ext uri="{FF2B5EF4-FFF2-40B4-BE49-F238E27FC236}">
-                <a16:creationId xmlns:a16="http://schemas.microsoft.com/office/drawing/2014/main" id="{DAE8151E-76AC-893E-C8A6-F6E4F7938B4E}"/>
-              </a:ext>
-            </a:extLst>
-          </p:cNvPr>
-          <p:cNvSpPr txBox="1"/>
-          <p:nvPr/>
-        </p:nvSpPr>
-        <p:spPr>
-          <a:xfrm>
-            <a:off x="6680200" y="2578100"/>
-            <a:ext cx="4622800" cy="292388"/>
-          </a:xfrm>
-          <a:prstGeom prst="rect">
-            <a:avLst/>
-          </a:prstGeom>
-          <a:noFill/>
-        </p:spPr>
-        <p:txBody>
-          <a:bodyPr vert="horz" wrap="square" lIns="0" tIns="0" rIns="0" bIns="0" rtlCol="0">
-            <a:spAutoFit/>
-          </a:bodyPr>
-          <a:lstStyle/>
-          <a:p>
-            <a:r>
-              <a:rPr lang="zh-CN" altLang="en-US" sz="1900" b="1">
-                <a:solidFill>
-                  <a:srgbClr val="1E252C"/>
-                </a:solidFill>
-                <a:latin typeface="Microsoft YaHei UI" panose="020B0503020204020204" pitchFamily="34" charset="-122"/>
-                <a:ea typeface="Microsoft YaHei UI" panose="020B0503020204020204" pitchFamily="34" charset="-122"/>
-              </a:rPr>
-              <a:t>老玩家：认可变化，但担心 </a:t>
-            </a:r>
-            <a:r>
-              <a:rPr lang="en-US" altLang="zh-CN" sz="1900" b="1">
-                <a:solidFill>
-                  <a:srgbClr val="1E252C"/>
-                </a:solidFill>
-                <a:latin typeface="Microsoft YaHei UI" panose="020B0503020204020204" pitchFamily="34" charset="-122"/>
-                <a:ea typeface="Microsoft YaHei UI" panose="020B0503020204020204" pitchFamily="34" charset="-122"/>
-              </a:rPr>
-              <a:t>GnG </a:t>
-            </a:r>
-            <a:r>
-              <a:rPr lang="zh-CN" altLang="en-US" sz="1900" b="1">
-                <a:solidFill>
-                  <a:srgbClr val="1E252C"/>
-                </a:solidFill>
-                <a:latin typeface="Microsoft YaHei UI" panose="020B0503020204020204" pitchFamily="34" charset="-122"/>
-                <a:ea typeface="Microsoft YaHei UI" panose="020B0503020204020204" pitchFamily="34" charset="-122"/>
-              </a:rPr>
-              <a:t>变浅</a:t>
-            </a:r>
-          </a:p>
-        </p:txBody>
-      </p:sp>
-      <p:sp>
-        <p:nvSpPr>
-          <p:cNvPr id="90" name="文本框 89">
-            <a:extLst>
-              <a:ext uri="{FF2B5EF4-FFF2-40B4-BE49-F238E27FC236}">
-                <a16:creationId xmlns:a16="http://schemas.microsoft.com/office/drawing/2014/main" id="{5FBB4FC8-D200-C740-5FDF-EF8897BD572D}"/>
-              </a:ext>
-            </a:extLst>
-          </p:cNvPr>
-          <p:cNvSpPr txBox="1"/>
-          <p:nvPr/>
-        </p:nvSpPr>
-        <p:spPr>
-          <a:xfrm>
-            <a:off x="6680200" y="2933700"/>
-            <a:ext cx="4622800" cy="161583"/>
-          </a:xfrm>
-          <a:prstGeom prst="rect">
-            <a:avLst/>
-          </a:prstGeom>
-          <a:noFill/>
-        </p:spPr>
-        <p:txBody>
-          <a:bodyPr vert="horz" wrap="square" lIns="0" tIns="0" rIns="0" bIns="0" rtlCol="0">
-            <a:spAutoFit/>
-          </a:bodyPr>
-          <a:lstStyle/>
-          <a:p>
-            <a:r>
-              <a:rPr lang="zh-CN" altLang="en-US" sz="1050">
-                <a:solidFill>
-                  <a:srgbClr val="64707A"/>
-                </a:solidFill>
-                <a:latin typeface="Microsoft YaHei UI" panose="020B0503020204020204" pitchFamily="34" charset="-122"/>
-                <a:ea typeface="Microsoft YaHei UI" panose="020B0503020204020204" pitchFamily="34" charset="-122"/>
-              </a:rPr>
-              <a:t>认可新增动作与反馈，但担心核心深度、压迫感和职业差异被削弱。</a:t>
-            </a:r>
-          </a:p>
-        </p:txBody>
-      </p:sp>
-      <p:sp>
-        <p:nvSpPr>
-          <p:cNvPr id="91" name="矩形: 圆角 90">
-            <a:extLst>
-              <a:ext uri="{FF2B5EF4-FFF2-40B4-BE49-F238E27FC236}">
-                <a16:creationId xmlns:a16="http://schemas.microsoft.com/office/drawing/2014/main" id="{D200791C-88A1-1C23-9595-2AAEB81F01A4}"/>
+              <a:t>认可操控优化，但担心战斗策略变浅</a:t>
+            </a:r>
+          </a:p>
+        </p:txBody>
+      </p:sp>
+      <p:sp>
+        <p:nvSpPr>
+          <p:cNvPr id="80" name="矩形: 圆角 79">
+            <a:extLst>
+              <a:ext uri="{FF2B5EF4-FFF2-40B4-BE49-F238E27FC236}">
+                <a16:creationId xmlns:a16="http://schemas.microsoft.com/office/drawing/2014/main" id="{E70A39DF-87F7-23A4-6304-B2B207061A02}"/>
               </a:ext>
             </a:extLst>
           </p:cNvPr>
@@ -7103,16 +6677,16 @@
         </p:nvSpPr>
         <p:spPr>
           <a:xfrm>
-            <a:off x="6680200" y="3302000"/>
-            <a:ext cx="4622800" cy="787400"/>
+            <a:off x="6747164" y="3435929"/>
+            <a:ext cx="4470400" cy="812800"/>
           </a:xfrm>
           <a:prstGeom prst="roundRect">
             <a:avLst>
-              <a:gd name="adj" fmla="val 12000"/>
+              <a:gd name="adj" fmla="val 10000"/>
             </a:avLst>
           </a:prstGeom>
           <a:solidFill>
-            <a:srgbClr val="FFF1E8"/>
+            <a:srgbClr val="162A2D"/>
           </a:solidFill>
           <a:ln w="19050" cap="flat" cmpd="sng" algn="ctr">
             <a:noFill/>
@@ -7161,10 +6735,10 @@
       </p:sp>
       <p:sp>
         <p:nvSpPr>
-          <p:cNvPr id="92" name="文本框 91">
-            <a:extLst>
-              <a:ext uri="{FF2B5EF4-FFF2-40B4-BE49-F238E27FC236}">
-                <a16:creationId xmlns:a16="http://schemas.microsoft.com/office/drawing/2014/main" id="{DDF96075-0860-97BE-39B0-07D38518F10D}"/>
+          <p:cNvPr id="81" name="文本框 80">
+            <a:extLst>
+              <a:ext uri="{FF2B5EF4-FFF2-40B4-BE49-F238E27FC236}">
+                <a16:creationId xmlns:a16="http://schemas.microsoft.com/office/drawing/2014/main" id="{DE2977B5-0E24-4A0F-A901-868FD25DADC7}"/>
               </a:ext>
             </a:extLst>
           </p:cNvPr>
@@ -7173,8 +6747,8 @@
         </p:nvSpPr>
         <p:spPr>
           <a:xfrm>
-            <a:off x="6858000" y="3429000"/>
-            <a:ext cx="698500" cy="176972"/>
+            <a:off x="6924964" y="3452091"/>
+            <a:ext cx="1206500" cy="184666"/>
           </a:xfrm>
           <a:prstGeom prst="rect">
             <a:avLst/>
@@ -7188,7 +6762,7 @@
           <a:lstStyle/>
           <a:p>
             <a:r>
-              <a:rPr lang="zh-CN" altLang="en-US" sz="1150" b="1">
+              <a:rPr lang="zh-CN" altLang="en-US" sz="1200" b="1">
                 <a:solidFill>
                   <a:srgbClr val="E26A3B"/>
                 </a:solidFill>
@@ -7202,10 +6776,10 @@
       </p:sp>
       <p:sp>
         <p:nvSpPr>
-          <p:cNvPr id="93" name="椭圆 92">
-            <a:extLst>
-              <a:ext uri="{FF2B5EF4-FFF2-40B4-BE49-F238E27FC236}">
-                <a16:creationId xmlns:a16="http://schemas.microsoft.com/office/drawing/2014/main" id="{FFFBAA4C-C514-200C-3394-DFA91F402991}"/>
+          <p:cNvPr id="82" name="椭圆 81">
+            <a:extLst>
+              <a:ext uri="{FF2B5EF4-FFF2-40B4-BE49-F238E27FC236}">
+                <a16:creationId xmlns:a16="http://schemas.microsoft.com/office/drawing/2014/main" id="{B66C0F3C-7188-98A7-6A7F-B59D1BEF4C9F}"/>
               </a:ext>
             </a:extLst>
           </p:cNvPr>
@@ -7214,7 +6788,7 @@
         </p:nvSpPr>
         <p:spPr>
           <a:xfrm>
-            <a:off x="6858000" y="3733800"/>
+            <a:off x="6924964" y="3769591"/>
             <a:ext cx="139700" cy="139700"/>
           </a:xfrm>
           <a:prstGeom prst="ellipse">
@@ -7286,10 +6860,10 @@
       </p:sp>
       <p:sp>
         <p:nvSpPr>
-          <p:cNvPr id="94" name="文本框 93">
-            <a:extLst>
-              <a:ext uri="{FF2B5EF4-FFF2-40B4-BE49-F238E27FC236}">
-                <a16:creationId xmlns:a16="http://schemas.microsoft.com/office/drawing/2014/main" id="{3BBFDBB5-85EF-FE7C-5091-F56ACE6EC531}"/>
+          <p:cNvPr id="83" name="文本框 82">
+            <a:extLst>
+              <a:ext uri="{FF2B5EF4-FFF2-40B4-BE49-F238E27FC236}">
+                <a16:creationId xmlns:a16="http://schemas.microsoft.com/office/drawing/2014/main" id="{B64A3D31-B1BE-6E52-600F-D483651D9602}"/>
               </a:ext>
             </a:extLst>
           </p:cNvPr>
@@ -7298,8 +6872,8 @@
         </p:nvSpPr>
         <p:spPr>
           <a:xfrm>
-            <a:off x="7073900" y="3721100"/>
-            <a:ext cx="4318000" cy="161583"/>
+            <a:off x="7153564" y="3734955"/>
+            <a:ext cx="4191000" cy="184666"/>
           </a:xfrm>
           <a:prstGeom prst="rect">
             <a:avLst/>
@@ -7313,9 +6887,9 @@
           <a:lstStyle/>
           <a:p>
             <a:r>
-              <a:rPr lang="zh-CN" altLang="en-US" sz="1050">
-                <a:solidFill>
-                  <a:srgbClr val="26313A"/>
+              <a:rPr lang="zh-CN" altLang="en-US" sz="1200">
+                <a:solidFill>
+                  <a:srgbClr val="D8E0E6"/>
                 </a:solidFill>
                 <a:latin typeface="Microsoft YaHei UI" panose="020B0503020204020204" pitchFamily="34" charset="-122"/>
                 <a:ea typeface="Microsoft YaHei UI" panose="020B0503020204020204" pitchFamily="34" charset="-122"/>
@@ -7327,10 +6901,10 @@
       </p:sp>
       <p:sp>
         <p:nvSpPr>
-          <p:cNvPr id="95" name="椭圆 94">
-            <a:extLst>
-              <a:ext uri="{FF2B5EF4-FFF2-40B4-BE49-F238E27FC236}">
-                <a16:creationId xmlns:a16="http://schemas.microsoft.com/office/drawing/2014/main" id="{098E38C9-8F8E-424E-C88E-6365B6FDC74E}"/>
+          <p:cNvPr id="84" name="椭圆 83">
+            <a:extLst>
+              <a:ext uri="{FF2B5EF4-FFF2-40B4-BE49-F238E27FC236}">
+                <a16:creationId xmlns:a16="http://schemas.microsoft.com/office/drawing/2014/main" id="{EF986BE5-DA5A-D417-D55D-6EAD73970BD4}"/>
               </a:ext>
             </a:extLst>
           </p:cNvPr>
@@ -7339,7 +6913,7 @@
         </p:nvSpPr>
         <p:spPr>
           <a:xfrm>
-            <a:off x="6858000" y="4013200"/>
+            <a:off x="6924964" y="4048991"/>
             <a:ext cx="139700" cy="139700"/>
           </a:xfrm>
           <a:prstGeom prst="ellipse">
@@ -7411,10 +6985,10 @@
       </p:sp>
       <p:sp>
         <p:nvSpPr>
-          <p:cNvPr id="96" name="文本框 95">
-            <a:extLst>
-              <a:ext uri="{FF2B5EF4-FFF2-40B4-BE49-F238E27FC236}">
-                <a16:creationId xmlns:a16="http://schemas.microsoft.com/office/drawing/2014/main" id="{FF9EFC7A-853E-DE78-6470-D94D9626A21C}"/>
+          <p:cNvPr id="85" name="文本框 84">
+            <a:extLst>
+              <a:ext uri="{FF2B5EF4-FFF2-40B4-BE49-F238E27FC236}">
+                <a16:creationId xmlns:a16="http://schemas.microsoft.com/office/drawing/2014/main" id="{CA4B17E4-10F5-FA26-1DDE-9E8F6D55B06E}"/>
               </a:ext>
             </a:extLst>
           </p:cNvPr>
@@ -7423,8 +6997,8 @@
         </p:nvSpPr>
         <p:spPr>
           <a:xfrm>
-            <a:off x="7073900" y="4000500"/>
-            <a:ext cx="4318000" cy="161583"/>
+            <a:off x="7153564" y="4023591"/>
+            <a:ext cx="4191000" cy="184666"/>
           </a:xfrm>
           <a:prstGeom prst="rect">
             <a:avLst/>
@@ -7438,9 +7012,9 @@
           <a:lstStyle/>
           <a:p>
             <a:r>
-              <a:rPr lang="zh-CN" altLang="en-US" sz="1050">
-                <a:solidFill>
-                  <a:srgbClr val="26313A"/>
+              <a:rPr lang="zh-CN" altLang="en-US" sz="1200">
+                <a:solidFill>
+                  <a:srgbClr val="D8E0E6"/>
                 </a:solidFill>
                 <a:latin typeface="Microsoft YaHei UI" panose="020B0503020204020204" pitchFamily="34" charset="-122"/>
                 <a:ea typeface="Microsoft YaHei UI" panose="020B0503020204020204" pitchFamily="34" charset="-122"/>
@@ -7452,10 +7026,10 @@
       </p:sp>
       <p:sp>
         <p:nvSpPr>
-          <p:cNvPr id="97" name="矩形: 圆角 96">
-            <a:extLst>
-              <a:ext uri="{FF2B5EF4-FFF2-40B4-BE49-F238E27FC236}">
-                <a16:creationId xmlns:a16="http://schemas.microsoft.com/office/drawing/2014/main" id="{0D7C853E-CF74-0AC7-210B-F8640FD1179F}"/>
+          <p:cNvPr id="86" name="矩形: 圆角 85">
+            <a:extLst>
+              <a:ext uri="{FF2B5EF4-FFF2-40B4-BE49-F238E27FC236}">
+                <a16:creationId xmlns:a16="http://schemas.microsoft.com/office/drawing/2014/main" id="{E3D48F98-7076-ECD0-575E-48D4198BA876}"/>
               </a:ext>
             </a:extLst>
           </p:cNvPr>
@@ -7464,16 +7038,16 @@
         </p:nvSpPr>
         <p:spPr>
           <a:xfrm>
-            <a:off x="6680200" y="4216400"/>
-            <a:ext cx="4622800" cy="914400"/>
+            <a:off x="6747164" y="4509651"/>
+            <a:ext cx="4470400" cy="1235306"/>
           </a:xfrm>
           <a:prstGeom prst="roundRect">
             <a:avLst>
-              <a:gd name="adj" fmla="val 12000"/>
+              <a:gd name="adj" fmla="val 10000"/>
             </a:avLst>
           </a:prstGeom>
           <a:solidFill>
-            <a:srgbClr val="FFF7F2"/>
+            <a:srgbClr val="221A18"/>
           </a:solidFill>
           <a:ln w="19050" cap="flat" cmpd="sng" algn="ctr">
             <a:noFill/>
@@ -7522,10 +7096,10 @@
       </p:sp>
       <p:sp>
         <p:nvSpPr>
-          <p:cNvPr id="98" name="文本框 97">
-            <a:extLst>
-              <a:ext uri="{FF2B5EF4-FFF2-40B4-BE49-F238E27FC236}">
-                <a16:creationId xmlns:a16="http://schemas.microsoft.com/office/drawing/2014/main" id="{4F35A6D3-5730-6933-52D8-B441281C1ED0}"/>
+          <p:cNvPr id="87" name="文本框 86">
+            <a:extLst>
+              <a:ext uri="{FF2B5EF4-FFF2-40B4-BE49-F238E27FC236}">
+                <a16:creationId xmlns:a16="http://schemas.microsoft.com/office/drawing/2014/main" id="{D0AE685F-BC0D-C2CD-DADA-2940418B21E4}"/>
               </a:ext>
             </a:extLst>
           </p:cNvPr>
@@ -7534,8 +7108,8 @@
         </p:nvSpPr>
         <p:spPr>
           <a:xfrm>
-            <a:off x="6858000" y="4330700"/>
-            <a:ext cx="1206500" cy="176972"/>
+            <a:off x="6924964" y="4544291"/>
+            <a:ext cx="1206500" cy="184666"/>
           </a:xfrm>
           <a:prstGeom prst="rect">
             <a:avLst/>
@@ -7549,9 +7123,9 @@
           <a:lstStyle/>
           <a:p>
             <a:r>
-              <a:rPr lang="zh-CN" altLang="en-US" sz="1150" b="1">
-                <a:solidFill>
-                  <a:srgbClr val="D65A3A"/>
+              <a:rPr lang="zh-CN" altLang="en-US" sz="1200" b="1">
+                <a:solidFill>
+                  <a:srgbClr val="FF6B52"/>
                 </a:solidFill>
                 <a:latin typeface="Microsoft YaHei UI" panose="020B0503020204020204" pitchFamily="34" charset="-122"/>
                 <a:ea typeface="Microsoft YaHei UI" panose="020B0503020204020204" pitchFamily="34" charset="-122"/>
@@ -7559,9 +7133,9 @@
               <a:t>阻碍 </a:t>
             </a:r>
             <a:r>
-              <a:rPr lang="en-US" altLang="zh-CN" sz="1150" b="1">
-                <a:solidFill>
-                  <a:srgbClr val="D65A3A"/>
+              <a:rPr lang="en-US" altLang="zh-CN" sz="1200" b="1">
+                <a:solidFill>
+                  <a:srgbClr val="FF6B52"/>
                 </a:solidFill>
                 <a:latin typeface="Microsoft YaHei UI" panose="020B0503020204020204" pitchFamily="34" charset="-122"/>
                 <a:ea typeface="Microsoft YaHei UI" panose="020B0503020204020204" pitchFamily="34" charset="-122"/>
@@ -7569,9 +7143,9 @@
               <a:t>/ </a:t>
             </a:r>
             <a:r>
-              <a:rPr lang="zh-CN" altLang="en-US" sz="1150" b="1">
-                <a:solidFill>
-                  <a:srgbClr val="D65A3A"/>
+              <a:rPr lang="zh-CN" altLang="en-US" sz="1200" b="1">
+                <a:solidFill>
+                  <a:srgbClr val="FF6B52"/>
                 </a:solidFill>
                 <a:latin typeface="Microsoft YaHei UI" panose="020B0503020204020204" pitchFamily="34" charset="-122"/>
                 <a:ea typeface="Microsoft YaHei UI" panose="020B0503020204020204" pitchFamily="34" charset="-122"/>
@@ -7583,10 +7157,10 @@
       </p:sp>
       <p:sp>
         <p:nvSpPr>
-          <p:cNvPr id="99" name="椭圆 98">
-            <a:extLst>
-              <a:ext uri="{FF2B5EF4-FFF2-40B4-BE49-F238E27FC236}">
-                <a16:creationId xmlns:a16="http://schemas.microsoft.com/office/drawing/2014/main" id="{7D20A174-E5CB-8EE0-06D8-98B6855DF1B8}"/>
+          <p:cNvPr id="88" name="椭圆 87">
+            <a:extLst>
+              <a:ext uri="{FF2B5EF4-FFF2-40B4-BE49-F238E27FC236}">
+                <a16:creationId xmlns:a16="http://schemas.microsoft.com/office/drawing/2014/main" id="{5EBD67A2-1843-CE11-6528-FBF6D636E58D}"/>
               </a:ext>
             </a:extLst>
           </p:cNvPr>
@@ -7595,14 +7169,14 @@
         </p:nvSpPr>
         <p:spPr>
           <a:xfrm>
-            <a:off x="6858000" y="4622800"/>
+            <a:off x="6924964" y="4861791"/>
             <a:ext cx="139700" cy="139700"/>
           </a:xfrm>
           <a:prstGeom prst="ellipse">
             <a:avLst/>
           </a:prstGeom>
           <a:solidFill>
-            <a:srgbClr val="D65A3A"/>
+            <a:srgbClr val="FF6B52"/>
           </a:solidFill>
           <a:ln w="19050" cap="flat" cmpd="sng" algn="ctr">
             <a:noFill/>
@@ -7667,10 +7241,10 @@
       </p:sp>
       <p:sp>
         <p:nvSpPr>
-          <p:cNvPr id="100" name="文本框 99">
-            <a:extLst>
-              <a:ext uri="{FF2B5EF4-FFF2-40B4-BE49-F238E27FC236}">
-                <a16:creationId xmlns:a16="http://schemas.microsoft.com/office/drawing/2014/main" id="{E408EFF2-DEEE-190B-633B-41CF7E4D84E2}"/>
+          <p:cNvPr id="89" name="文本框 88">
+            <a:extLst>
+              <a:ext uri="{FF2B5EF4-FFF2-40B4-BE49-F238E27FC236}">
+                <a16:creationId xmlns:a16="http://schemas.microsoft.com/office/drawing/2014/main" id="{3E8C4374-FA49-0C69-8819-23160C2B6668}"/>
               </a:ext>
             </a:extLst>
           </p:cNvPr>
@@ -7679,8 +7253,8 @@
         </p:nvSpPr>
         <p:spPr>
           <a:xfrm>
-            <a:off x="7073900" y="4610100"/>
-            <a:ext cx="4318000" cy="161583"/>
+            <a:off x="7153564" y="4836391"/>
+            <a:ext cx="4191000" cy="184666"/>
           </a:xfrm>
           <a:prstGeom prst="rect">
             <a:avLst/>
@@ -7694,9 +7268,9 @@
           <a:lstStyle/>
           <a:p>
             <a:r>
-              <a:rPr lang="zh-CN" altLang="en-US" sz="1050">
-                <a:solidFill>
-                  <a:srgbClr val="26313A"/>
+              <a:rPr lang="zh-CN" altLang="en-US" sz="1200">
+                <a:solidFill>
+                  <a:srgbClr val="D8E0E6"/>
                 </a:solidFill>
                 <a:latin typeface="Microsoft YaHei UI" panose="020B0503020204020204" pitchFamily="34" charset="-122"/>
                 <a:ea typeface="Microsoft YaHei UI" panose="020B0503020204020204" pitchFamily="34" charset="-122"/>
@@ -7708,10 +7282,10 @@
       </p:sp>
       <p:sp>
         <p:nvSpPr>
-          <p:cNvPr id="101" name="椭圆 100">
-            <a:extLst>
-              <a:ext uri="{FF2B5EF4-FFF2-40B4-BE49-F238E27FC236}">
-                <a16:creationId xmlns:a16="http://schemas.microsoft.com/office/drawing/2014/main" id="{4484F7B4-7793-8E04-4056-FB48B17C495E}"/>
+          <p:cNvPr id="90" name="椭圆 89">
+            <a:extLst>
+              <a:ext uri="{FF2B5EF4-FFF2-40B4-BE49-F238E27FC236}">
+                <a16:creationId xmlns:a16="http://schemas.microsoft.com/office/drawing/2014/main" id="{EC2EC064-E005-E2D3-61AC-33512070509F}"/>
               </a:ext>
             </a:extLst>
           </p:cNvPr>
@@ -7720,14 +7294,14 @@
         </p:nvSpPr>
         <p:spPr>
           <a:xfrm>
-            <a:off x="6858000" y="4864100"/>
+            <a:off x="6924964" y="5141191"/>
             <a:ext cx="139700" cy="139700"/>
           </a:xfrm>
           <a:prstGeom prst="ellipse">
             <a:avLst/>
           </a:prstGeom>
           <a:solidFill>
-            <a:srgbClr val="D65A3A"/>
+            <a:srgbClr val="FF6B52"/>
           </a:solidFill>
           <a:ln w="19050" cap="flat" cmpd="sng" algn="ctr">
             <a:noFill/>
@@ -7792,10 +7366,10 @@
       </p:sp>
       <p:sp>
         <p:nvSpPr>
-          <p:cNvPr id="102" name="文本框 101">
-            <a:extLst>
-              <a:ext uri="{FF2B5EF4-FFF2-40B4-BE49-F238E27FC236}">
-                <a16:creationId xmlns:a16="http://schemas.microsoft.com/office/drawing/2014/main" id="{C0F079E1-8F7F-E592-6141-6B94307AA504}"/>
+          <p:cNvPr id="91" name="文本框 90">
+            <a:extLst>
+              <a:ext uri="{FF2B5EF4-FFF2-40B4-BE49-F238E27FC236}">
+                <a16:creationId xmlns:a16="http://schemas.microsoft.com/office/drawing/2014/main" id="{852F9A93-3E7E-EE07-9985-95C661779BA6}"/>
               </a:ext>
             </a:extLst>
           </p:cNvPr>
@@ -7804,8 +7378,8 @@
         </p:nvSpPr>
         <p:spPr>
           <a:xfrm>
-            <a:off x="7073900" y="4851400"/>
-            <a:ext cx="4318000" cy="161583"/>
+            <a:off x="7153564" y="5115791"/>
+            <a:ext cx="4191000" cy="184666"/>
           </a:xfrm>
           <a:prstGeom prst="rect">
             <a:avLst/>
@@ -7819,9 +7393,9 @@
           <a:lstStyle/>
           <a:p>
             <a:r>
-              <a:rPr lang="zh-CN" altLang="en-US" sz="1050">
-                <a:solidFill>
-                  <a:srgbClr val="26313A"/>
+              <a:rPr lang="zh-CN" altLang="en-US" sz="1200">
+                <a:solidFill>
+                  <a:srgbClr val="D8E0E6"/>
                 </a:solidFill>
                 <a:latin typeface="Microsoft YaHei UI" panose="020B0503020204020204" pitchFamily="34" charset="-122"/>
                 <a:ea typeface="Microsoft YaHei UI" panose="020B0503020204020204" pitchFamily="34" charset="-122"/>
@@ -7833,10 +7407,10 @@
       </p:sp>
       <p:sp>
         <p:nvSpPr>
-          <p:cNvPr id="103" name="椭圆 102">
-            <a:extLst>
-              <a:ext uri="{FF2B5EF4-FFF2-40B4-BE49-F238E27FC236}">
-                <a16:creationId xmlns:a16="http://schemas.microsoft.com/office/drawing/2014/main" id="{E1EF8D47-EC2A-7B12-1586-387D28B3E928}"/>
+          <p:cNvPr id="92" name="椭圆 91">
+            <a:extLst>
+              <a:ext uri="{FF2B5EF4-FFF2-40B4-BE49-F238E27FC236}">
+                <a16:creationId xmlns:a16="http://schemas.microsoft.com/office/drawing/2014/main" id="{6617B9E9-2ADA-2574-5466-F98E685D7F77}"/>
               </a:ext>
             </a:extLst>
           </p:cNvPr>
@@ -7845,14 +7419,14 @@
         </p:nvSpPr>
         <p:spPr>
           <a:xfrm>
-            <a:off x="6858000" y="5105400"/>
+            <a:off x="6924964" y="5420591"/>
             <a:ext cx="139700" cy="139700"/>
           </a:xfrm>
           <a:prstGeom prst="ellipse">
             <a:avLst/>
           </a:prstGeom>
           <a:solidFill>
-            <a:srgbClr val="D65A3A"/>
+            <a:srgbClr val="FF6B52"/>
           </a:solidFill>
           <a:ln w="19050" cap="flat" cmpd="sng" algn="ctr">
             <a:noFill/>
@@ -7917,10 +7491,10 @@
       </p:sp>
       <p:sp>
         <p:nvSpPr>
-          <p:cNvPr id="104" name="文本框 103">
-            <a:extLst>
-              <a:ext uri="{FF2B5EF4-FFF2-40B4-BE49-F238E27FC236}">
-                <a16:creationId xmlns:a16="http://schemas.microsoft.com/office/drawing/2014/main" id="{777C9562-425A-5565-606B-A1DBBEC4D642}"/>
+          <p:cNvPr id="93" name="文本框 92">
+            <a:extLst>
+              <a:ext uri="{FF2B5EF4-FFF2-40B4-BE49-F238E27FC236}">
+                <a16:creationId xmlns:a16="http://schemas.microsoft.com/office/drawing/2014/main" id="{9EADA2DF-5ECA-ED1D-590A-BB184E52E285}"/>
               </a:ext>
             </a:extLst>
           </p:cNvPr>
@@ -7929,8 +7503,8 @@
         </p:nvSpPr>
         <p:spPr>
           <a:xfrm>
-            <a:off x="7073900" y="5092700"/>
-            <a:ext cx="4318000" cy="161583"/>
+            <a:off x="7153564" y="5395191"/>
+            <a:ext cx="4191000" cy="184666"/>
           </a:xfrm>
           <a:prstGeom prst="rect">
             <a:avLst/>
@@ -7944,65 +7518,24 @@
           <a:lstStyle/>
           <a:p>
             <a:r>
-              <a:rPr lang="zh-CN" altLang="en-US" sz="1050">
-                <a:solidFill>
-                  <a:srgbClr val="26313A"/>
+              <a:rPr lang="zh-CN" altLang="en-US" sz="1200">
+                <a:solidFill>
+                  <a:srgbClr val="D8E0E6"/>
                 </a:solidFill>
                 <a:latin typeface="Microsoft YaHei UI" panose="020B0503020204020204" pitchFamily="34" charset="-122"/>
                 <a:ea typeface="Microsoft YaHei UI" panose="020B0503020204020204" pitchFamily="34" charset="-122"/>
               </a:rPr>
-              <a:t>通用防御削弱职业差异</a:t>
-            </a:r>
-          </a:p>
-        </p:txBody>
-      </p:sp>
-      <p:sp>
-        <p:nvSpPr>
-          <p:cNvPr id="105" name="文本框 104">
-            <a:extLst>
-              <a:ext uri="{FF2B5EF4-FFF2-40B4-BE49-F238E27FC236}">
-                <a16:creationId xmlns:a16="http://schemas.microsoft.com/office/drawing/2014/main" id="{242934E8-A5C3-8A7D-55DA-E2EA59BBA657}"/>
-              </a:ext>
-            </a:extLst>
-          </p:cNvPr>
-          <p:cNvSpPr txBox="1"/>
-          <p:nvPr/>
-        </p:nvSpPr>
-        <p:spPr>
-          <a:xfrm>
-            <a:off x="609600" y="5384800"/>
-            <a:ext cx="1143000" cy="200055"/>
-          </a:xfrm>
-          <a:prstGeom prst="rect">
-            <a:avLst/>
-          </a:prstGeom>
-          <a:noFill/>
-        </p:spPr>
-        <p:txBody>
-          <a:bodyPr vert="horz" wrap="square" lIns="0" tIns="0" rIns="0" bIns="0" rtlCol="0">
-            <a:spAutoFit/>
-          </a:bodyPr>
-          <a:lstStyle/>
-          <a:p>
-            <a:r>
-              <a:rPr lang="zh-CN" altLang="en-US" sz="1300" b="1">
-                <a:solidFill>
-                  <a:srgbClr val="1E252C"/>
-                </a:solidFill>
-                <a:latin typeface="Microsoft YaHei UI" panose="020B0503020204020204" pitchFamily="34" charset="-122"/>
-                <a:ea typeface="Microsoft YaHei UI" panose="020B0503020204020204" pitchFamily="34" charset="-122"/>
-              </a:rPr>
-              <a:t>优先级</a:t>
-            </a:r>
-          </a:p>
-        </p:txBody>
-      </p:sp>
-      <p:sp>
-        <p:nvSpPr>
-          <p:cNvPr id="106" name="矩形: 圆角 105">
-            <a:extLst>
-              <a:ext uri="{FF2B5EF4-FFF2-40B4-BE49-F238E27FC236}">
-                <a16:creationId xmlns:a16="http://schemas.microsoft.com/office/drawing/2014/main" id="{C6042B5D-19B5-515E-0A04-8DE6467A4C4E}"/>
+              <a:t>通用格挡削弱职业差异</a:t>
+            </a:r>
+          </a:p>
+        </p:txBody>
+      </p:sp>
+      <p:sp>
+        <p:nvSpPr>
+          <p:cNvPr id="2" name="矩形: 圆角 1">
+            <a:extLst>
+              <a:ext uri="{FF2B5EF4-FFF2-40B4-BE49-F238E27FC236}">
+                <a16:creationId xmlns:a16="http://schemas.microsoft.com/office/drawing/2014/main" id="{3D66078B-28AA-B8C6-C0A5-7B7EE6B3E4BC}"/>
               </a:ext>
             </a:extLst>
           </p:cNvPr>
@@ -8011,16 +7544,16 @@
         </p:nvSpPr>
         <p:spPr>
           <a:xfrm>
-            <a:off x="609600" y="5689600"/>
-            <a:ext cx="3454400" cy="635000"/>
+            <a:off x="6934200" y="2385868"/>
+            <a:ext cx="1092200" cy="279400"/>
           </a:xfrm>
           <a:prstGeom prst="roundRect">
             <a:avLst>
-              <a:gd name="adj" fmla="val 12000"/>
+              <a:gd name="adj" fmla="val 50000"/>
             </a:avLst>
           </a:prstGeom>
           <a:solidFill>
-            <a:srgbClr val="EAF3F7"/>
+            <a:schemeClr val="accent2"/>
           </a:solidFill>
           <a:ln w="19050" cap="flat" cmpd="sng" algn="ctr">
             <a:noFill/>
@@ -8028,19 +7561,6 @@
             <a:miter lim="800000"/>
           </a:ln>
           <a:effectLst/>
-          <a:extLst>
-            <a:ext uri="{91240B29-F687-4F45-9708-019B960494DF}">
-              <a14:hiddenLine xmlns:a14="http://schemas.microsoft.com/office/drawing/2010/main" w="19050" cap="flat" cmpd="sng" algn="ctr">
-                <a:solidFill>
-                  <a:schemeClr val="accent1">
-                    <a:shade val="15000"/>
-                  </a:schemeClr>
-                </a:solidFill>
-                <a:prstDash val="solid"/>
-                <a:miter lim="800000"/>
-              </a14:hiddenLine>
-            </a:ext>
-          </a:extLst>
         </p:spPr>
         <p:style>
           <a:lnRef idx="2">
@@ -8063,700 +7583,17 @@
           <a:lstStyle/>
           <a:p>
             <a:pPr algn="ctr"/>
-            <a:endParaRPr lang="zh-CN" altLang="en-US"/>
-          </a:p>
-        </p:txBody>
-      </p:sp>
-      <p:sp>
-        <p:nvSpPr>
-          <p:cNvPr id="107" name="矩形: 圆角 106">
-            <a:extLst>
-              <a:ext uri="{FF2B5EF4-FFF2-40B4-BE49-F238E27FC236}">
-                <a16:creationId xmlns:a16="http://schemas.microsoft.com/office/drawing/2014/main" id="{9F579E03-64E4-8751-4EDC-00EEE1A24CE8}"/>
-              </a:ext>
-            </a:extLst>
-          </p:cNvPr>
-          <p:cNvSpPr/>
-          <p:nvPr/>
-        </p:nvSpPr>
-        <p:spPr>
-          <a:xfrm>
-            <a:off x="787400" y="5867400"/>
-            <a:ext cx="571500" cy="279400"/>
-          </a:xfrm>
-          <a:prstGeom prst="roundRect">
-            <a:avLst>
-              <a:gd name="adj" fmla="val 50000"/>
-            </a:avLst>
-          </a:prstGeom>
-          <a:solidFill>
-            <a:srgbClr val="D8463F"/>
-          </a:solidFill>
-          <a:ln w="19050" cap="flat" cmpd="sng" algn="ctr">
-            <a:noFill/>
-            <a:prstDash val="solid"/>
-            <a:miter lim="800000"/>
-          </a:ln>
-          <a:effectLst/>
-          <a:extLst>
-            <a:ext uri="{91240B29-F687-4F45-9708-019B960494DF}">
-              <a14:hiddenLine xmlns:a14="http://schemas.microsoft.com/office/drawing/2010/main" w="19050" cap="flat" cmpd="sng" algn="ctr">
-                <a:solidFill>
-                  <a:schemeClr val="accent1">
-                    <a:shade val="15000"/>
-                  </a:schemeClr>
-                </a:solidFill>
-                <a:prstDash val="solid"/>
-                <a:miter lim="800000"/>
-              </a14:hiddenLine>
-            </a:ext>
-          </a:extLst>
-        </p:spPr>
-        <p:style>
-          <a:lnRef idx="2">
-            <a:schemeClr val="accent1">
-              <a:shade val="15000"/>
-            </a:schemeClr>
-          </a:lnRef>
-          <a:fillRef idx="1">
-            <a:schemeClr val="accent1"/>
-          </a:fillRef>
-          <a:effectRef idx="0">
-            <a:schemeClr val="accent1"/>
-          </a:effectRef>
-          <a:fontRef idx="minor">
-            <a:schemeClr val="lt1"/>
-          </a:fontRef>
-        </p:style>
-        <p:txBody>
-          <a:bodyPr rtlCol="0" anchor="ctr"/>
-          <a:lstStyle/>
-          <a:p>
-            <a:pPr algn="ctr"/>
-            <a:endParaRPr lang="zh-CN" altLang="en-US"/>
-          </a:p>
-        </p:txBody>
-      </p:sp>
-      <p:sp>
-        <p:nvSpPr>
-          <p:cNvPr id="108" name="文本框 107">
-            <a:extLst>
-              <a:ext uri="{FF2B5EF4-FFF2-40B4-BE49-F238E27FC236}">
-                <a16:creationId xmlns:a16="http://schemas.microsoft.com/office/drawing/2014/main" id="{8020877F-C964-6BB4-9884-B69D12EB343B}"/>
-              </a:ext>
-            </a:extLst>
-          </p:cNvPr>
-          <p:cNvSpPr txBox="1"/>
-          <p:nvPr/>
-        </p:nvSpPr>
-        <p:spPr>
-          <a:xfrm>
-            <a:off x="787400" y="5918200"/>
-            <a:ext cx="571500" cy="130805"/>
-          </a:xfrm>
-          <a:prstGeom prst="rect">
-            <a:avLst/>
-          </a:prstGeom>
-          <a:noFill/>
-        </p:spPr>
-        <p:txBody>
-          <a:bodyPr vert="horz" wrap="square" lIns="0" tIns="0" rIns="0" bIns="0" rtlCol="0">
-            <a:spAutoFit/>
-          </a:bodyPr>
-          <a:lstStyle/>
-          <a:p>
-            <a:pPr algn="ctr"/>
-            <a:r>
-              <a:rPr lang="en-US" altLang="zh-CN" sz="850" b="1">
-                <a:solidFill>
-                  <a:srgbClr val="FFFFFF"/>
+            <a:r>
+              <a:rPr lang="zh-CN" altLang="en-US" sz="1600" b="1" dirty="0">
+                <a:solidFill>
+                  <a:srgbClr val="F8F6EF"/>
                 </a:solidFill>
                 <a:latin typeface="Microsoft YaHei UI" panose="020B0503020204020204" pitchFamily="34" charset="-122"/>
                 <a:ea typeface="Microsoft YaHei UI" panose="020B0503020204020204" pitchFamily="34" charset="-122"/>
               </a:rPr>
-              <a:t>P0</a:t>
-            </a:r>
-            <a:endParaRPr lang="zh-CN" altLang="en-US" sz="850" b="1">
-              <a:solidFill>
-                <a:srgbClr val="FFFFFF"/>
-              </a:solidFill>
-              <a:latin typeface="Microsoft YaHei UI" panose="020B0503020204020204" pitchFamily="34" charset="-122"/>
-              <a:ea typeface="Microsoft YaHei UI" panose="020B0503020204020204" pitchFamily="34" charset="-122"/>
-            </a:endParaRPr>
-          </a:p>
-        </p:txBody>
-      </p:sp>
-      <p:sp>
-        <p:nvSpPr>
-          <p:cNvPr id="109" name="文本框 108">
-            <a:extLst>
-              <a:ext uri="{FF2B5EF4-FFF2-40B4-BE49-F238E27FC236}">
-                <a16:creationId xmlns:a16="http://schemas.microsoft.com/office/drawing/2014/main" id="{20D51454-AB19-55C5-75CC-11E8BC0478FA}"/>
-              </a:ext>
-            </a:extLst>
-          </p:cNvPr>
-          <p:cNvSpPr txBox="1"/>
-          <p:nvPr/>
-        </p:nvSpPr>
-        <p:spPr>
-          <a:xfrm>
-            <a:off x="1524000" y="5816600"/>
-            <a:ext cx="2336800" cy="323165"/>
-          </a:xfrm>
-          <a:prstGeom prst="rect">
-            <a:avLst/>
-          </a:prstGeom>
-          <a:noFill/>
-        </p:spPr>
-        <p:txBody>
-          <a:bodyPr vert="horz" wrap="square" lIns="0" tIns="0" rIns="0" bIns="0" rtlCol="0">
-            <a:spAutoFit/>
-          </a:bodyPr>
-          <a:lstStyle/>
-          <a:p>
-            <a:r>
-              <a:rPr lang="zh-CN" altLang="en-US" sz="1050">
-                <a:solidFill>
-                  <a:srgbClr val="1E252C"/>
-                </a:solidFill>
-                <a:latin typeface="Microsoft YaHei UI" panose="020B0503020204020204" pitchFamily="34" charset="-122"/>
-                <a:ea typeface="Microsoft YaHei UI" panose="020B0503020204020204" pitchFamily="34" charset="-122"/>
-              </a:rPr>
-              <a:t>镜头 </a:t>
-            </a:r>
-            <a:r>
-              <a:rPr lang="en-US" altLang="zh-CN" sz="1050">
-                <a:solidFill>
-                  <a:srgbClr val="1E252C"/>
-                </a:solidFill>
-                <a:latin typeface="Microsoft YaHei UI" panose="020B0503020204020204" pitchFamily="34" charset="-122"/>
-                <a:ea typeface="Microsoft YaHei UI" panose="020B0503020204020204" pitchFamily="34" charset="-122"/>
-              </a:rPr>
-              <a:t>+ </a:t>
-            </a:r>
-            <a:r>
-              <a:rPr lang="zh-CN" altLang="en-US" sz="1050">
-                <a:solidFill>
-                  <a:srgbClr val="1E252C"/>
-                </a:solidFill>
-                <a:latin typeface="Microsoft YaHei UI" panose="020B0503020204020204" pitchFamily="34" charset="-122"/>
-                <a:ea typeface="Microsoft YaHei UI" panose="020B0503020204020204" pitchFamily="34" charset="-122"/>
-              </a:rPr>
-              <a:t>锁敌 </a:t>
-            </a:r>
-            <a:r>
-              <a:rPr lang="en-US" altLang="zh-CN" sz="1050">
-                <a:solidFill>
-                  <a:srgbClr val="1E252C"/>
-                </a:solidFill>
-                <a:latin typeface="Microsoft YaHei UI" panose="020B0503020204020204" pitchFamily="34" charset="-122"/>
-                <a:ea typeface="Microsoft YaHei UI" panose="020B0503020204020204" pitchFamily="34" charset="-122"/>
-              </a:rPr>
-              <a:t>+ </a:t>
-            </a:r>
-            <a:r>
-              <a:rPr lang="zh-CN" altLang="en-US" sz="1050">
-                <a:solidFill>
-                  <a:srgbClr val="1E252C"/>
-                </a:solidFill>
-                <a:latin typeface="Microsoft YaHei UI" panose="020B0503020204020204" pitchFamily="34" charset="-122"/>
-                <a:ea typeface="Microsoft YaHei UI" panose="020B0503020204020204" pitchFamily="34" charset="-122"/>
-              </a:rPr>
-              <a:t>操作按钮 </a:t>
-            </a:r>
-            <a:r>
-              <a:rPr lang="en-US" altLang="zh-CN" sz="1050">
-                <a:solidFill>
-                  <a:srgbClr val="1E252C"/>
-                </a:solidFill>
-                <a:latin typeface="Microsoft YaHei UI" panose="020B0503020204020204" pitchFamily="34" charset="-122"/>
-                <a:ea typeface="Microsoft YaHei UI" panose="020B0503020204020204" pitchFamily="34" charset="-122"/>
-              </a:rPr>
-              <a:t>+ </a:t>
-            </a:r>
-            <a:r>
-              <a:rPr lang="zh-CN" altLang="en-US" sz="1050">
-                <a:solidFill>
-                  <a:srgbClr val="1E252C"/>
-                </a:solidFill>
-                <a:latin typeface="Microsoft YaHei UI" panose="020B0503020204020204" pitchFamily="34" charset="-122"/>
-                <a:ea typeface="Microsoft YaHei UI" panose="020B0503020204020204" pitchFamily="34" charset="-122"/>
-              </a:rPr>
-              <a:t>战斗信息可读性</a:t>
-            </a:r>
-          </a:p>
-        </p:txBody>
-      </p:sp>
-      <p:sp>
-        <p:nvSpPr>
-          <p:cNvPr id="110" name="矩形: 圆角 109">
-            <a:extLst>
-              <a:ext uri="{FF2B5EF4-FFF2-40B4-BE49-F238E27FC236}">
-                <a16:creationId xmlns:a16="http://schemas.microsoft.com/office/drawing/2014/main" id="{78376D44-696B-86EE-25AE-AA914BB49154}"/>
-              </a:ext>
-            </a:extLst>
-          </p:cNvPr>
-          <p:cNvSpPr/>
-          <p:nvPr/>
-        </p:nvSpPr>
-        <p:spPr>
-          <a:xfrm>
-            <a:off x="4368800" y="5689600"/>
-            <a:ext cx="3454400" cy="635000"/>
-          </a:xfrm>
-          <a:prstGeom prst="roundRect">
-            <a:avLst>
-              <a:gd name="adj" fmla="val 12000"/>
-            </a:avLst>
-          </a:prstGeom>
-          <a:solidFill>
-            <a:srgbClr val="FFF4E8"/>
-          </a:solidFill>
-          <a:ln w="19050" cap="flat" cmpd="sng" algn="ctr">
-            <a:noFill/>
-            <a:prstDash val="solid"/>
-            <a:miter lim="800000"/>
-          </a:ln>
-          <a:effectLst/>
-          <a:extLst>
-            <a:ext uri="{91240B29-F687-4F45-9708-019B960494DF}">
-              <a14:hiddenLine xmlns:a14="http://schemas.microsoft.com/office/drawing/2010/main" w="19050" cap="flat" cmpd="sng" algn="ctr">
-                <a:solidFill>
-                  <a:schemeClr val="accent1">
-                    <a:shade val="15000"/>
-                  </a:schemeClr>
-                </a:solidFill>
-                <a:prstDash val="solid"/>
-                <a:miter lim="800000"/>
-              </a14:hiddenLine>
-            </a:ext>
-          </a:extLst>
-        </p:spPr>
-        <p:style>
-          <a:lnRef idx="2">
-            <a:schemeClr val="accent1">
-              <a:shade val="15000"/>
-            </a:schemeClr>
-          </a:lnRef>
-          <a:fillRef idx="1">
-            <a:schemeClr val="accent1"/>
-          </a:fillRef>
-          <a:effectRef idx="0">
-            <a:schemeClr val="accent1"/>
-          </a:effectRef>
-          <a:fontRef idx="minor">
-            <a:schemeClr val="lt1"/>
-          </a:fontRef>
-        </p:style>
-        <p:txBody>
-          <a:bodyPr rtlCol="0" anchor="ctr"/>
-          <a:lstStyle/>
-          <a:p>
-            <a:pPr algn="ctr"/>
-            <a:endParaRPr lang="zh-CN" altLang="en-US"/>
-          </a:p>
-        </p:txBody>
-      </p:sp>
-      <p:sp>
-        <p:nvSpPr>
-          <p:cNvPr id="111" name="矩形: 圆角 110">
-            <a:extLst>
-              <a:ext uri="{FF2B5EF4-FFF2-40B4-BE49-F238E27FC236}">
-                <a16:creationId xmlns:a16="http://schemas.microsoft.com/office/drawing/2014/main" id="{341B2E75-DF6F-CEE0-42B8-021496F5E29C}"/>
-              </a:ext>
-            </a:extLst>
-          </p:cNvPr>
-          <p:cNvSpPr/>
-          <p:nvPr/>
-        </p:nvSpPr>
-        <p:spPr>
-          <a:xfrm>
-            <a:off x="4546600" y="5867400"/>
-            <a:ext cx="571500" cy="279400"/>
-          </a:xfrm>
-          <a:prstGeom prst="roundRect">
-            <a:avLst>
-              <a:gd name="adj" fmla="val 50000"/>
-            </a:avLst>
-          </a:prstGeom>
-          <a:solidFill>
-            <a:srgbClr val="E78A2F"/>
-          </a:solidFill>
-          <a:ln w="19050" cap="flat" cmpd="sng" algn="ctr">
-            <a:noFill/>
-            <a:prstDash val="solid"/>
-            <a:miter lim="800000"/>
-          </a:ln>
-          <a:effectLst/>
-          <a:extLst>
-            <a:ext uri="{91240B29-F687-4F45-9708-019B960494DF}">
-              <a14:hiddenLine xmlns:a14="http://schemas.microsoft.com/office/drawing/2010/main" w="19050" cap="flat" cmpd="sng" algn="ctr">
-                <a:solidFill>
-                  <a:schemeClr val="accent1">
-                    <a:shade val="15000"/>
-                  </a:schemeClr>
-                </a:solidFill>
-                <a:prstDash val="solid"/>
-                <a:miter lim="800000"/>
-              </a14:hiddenLine>
-            </a:ext>
-          </a:extLst>
-        </p:spPr>
-        <p:style>
-          <a:lnRef idx="2">
-            <a:schemeClr val="accent1">
-              <a:shade val="15000"/>
-            </a:schemeClr>
-          </a:lnRef>
-          <a:fillRef idx="1">
-            <a:schemeClr val="accent1"/>
-          </a:fillRef>
-          <a:effectRef idx="0">
-            <a:schemeClr val="accent1"/>
-          </a:effectRef>
-          <a:fontRef idx="minor">
-            <a:schemeClr val="lt1"/>
-          </a:fontRef>
-        </p:style>
-        <p:txBody>
-          <a:bodyPr rtlCol="0" anchor="ctr"/>
-          <a:lstStyle/>
-          <a:p>
-            <a:pPr algn="ctr"/>
-            <a:endParaRPr lang="zh-CN" altLang="en-US"/>
-          </a:p>
-        </p:txBody>
-      </p:sp>
-      <p:sp>
-        <p:nvSpPr>
-          <p:cNvPr id="112" name="文本框 111">
-            <a:extLst>
-              <a:ext uri="{FF2B5EF4-FFF2-40B4-BE49-F238E27FC236}">
-                <a16:creationId xmlns:a16="http://schemas.microsoft.com/office/drawing/2014/main" id="{78F98AFD-7BF6-A212-E18B-3B402BC26AE4}"/>
-              </a:ext>
-            </a:extLst>
-          </p:cNvPr>
-          <p:cNvSpPr txBox="1"/>
-          <p:nvPr/>
-        </p:nvSpPr>
-        <p:spPr>
-          <a:xfrm>
-            <a:off x="4546600" y="5918200"/>
-            <a:ext cx="571500" cy="130805"/>
-          </a:xfrm>
-          <a:prstGeom prst="rect">
-            <a:avLst/>
-          </a:prstGeom>
-          <a:noFill/>
-        </p:spPr>
-        <p:txBody>
-          <a:bodyPr vert="horz" wrap="square" lIns="0" tIns="0" rIns="0" bIns="0" rtlCol="0">
-            <a:spAutoFit/>
-          </a:bodyPr>
-          <a:lstStyle/>
-          <a:p>
-            <a:pPr algn="ctr"/>
-            <a:r>
-              <a:rPr lang="en-US" altLang="zh-CN" sz="850" b="1">
-                <a:solidFill>
-                  <a:srgbClr val="FFFFFF"/>
-                </a:solidFill>
-                <a:latin typeface="Microsoft YaHei UI" panose="020B0503020204020204" pitchFamily="34" charset="-122"/>
-                <a:ea typeface="Microsoft YaHei UI" panose="020B0503020204020204" pitchFamily="34" charset="-122"/>
-              </a:rPr>
-              <a:t>P1</a:t>
-            </a:r>
-            <a:endParaRPr lang="zh-CN" altLang="en-US" sz="850" b="1">
-              <a:solidFill>
-                <a:srgbClr val="FFFFFF"/>
-              </a:solidFill>
-              <a:latin typeface="Microsoft YaHei UI" panose="020B0503020204020204" pitchFamily="34" charset="-122"/>
-              <a:ea typeface="Microsoft YaHei UI" panose="020B0503020204020204" pitchFamily="34" charset="-122"/>
-            </a:endParaRPr>
-          </a:p>
-        </p:txBody>
-      </p:sp>
-      <p:sp>
-        <p:nvSpPr>
-          <p:cNvPr id="113" name="文本框 112">
-            <a:extLst>
-              <a:ext uri="{FF2B5EF4-FFF2-40B4-BE49-F238E27FC236}">
-                <a16:creationId xmlns:a16="http://schemas.microsoft.com/office/drawing/2014/main" id="{BC4AB402-FAB3-D5DD-2ADE-F1C9E6A61F0C}"/>
-              </a:ext>
-            </a:extLst>
-          </p:cNvPr>
-          <p:cNvSpPr txBox="1"/>
-          <p:nvPr/>
-        </p:nvSpPr>
-        <p:spPr>
-          <a:xfrm>
-            <a:off x="5283200" y="5816600"/>
-            <a:ext cx="2336800" cy="323165"/>
-          </a:xfrm>
-          <a:prstGeom prst="rect">
-            <a:avLst/>
-          </a:prstGeom>
-          <a:noFill/>
-        </p:spPr>
-        <p:txBody>
-          <a:bodyPr vert="horz" wrap="square" lIns="0" tIns="0" rIns="0" bIns="0" rtlCol="0">
-            <a:spAutoFit/>
-          </a:bodyPr>
-          <a:lstStyle/>
-          <a:p>
-            <a:r>
-              <a:rPr lang="zh-CN" altLang="en-US" sz="1050">
-                <a:solidFill>
-                  <a:srgbClr val="1E252C"/>
-                </a:solidFill>
-                <a:latin typeface="Microsoft YaHei UI" panose="020B0503020204020204" pitchFamily="34" charset="-122"/>
-                <a:ea typeface="Microsoft YaHei UI" panose="020B0503020204020204" pitchFamily="34" charset="-122"/>
-              </a:rPr>
-              <a:t>职业差异、武器格挡规则、远程技能瞄准、</a:t>
-            </a:r>
-            <a:r>
-              <a:rPr lang="en-US" altLang="zh-CN" sz="1050">
-                <a:solidFill>
-                  <a:srgbClr val="1E252C"/>
-                </a:solidFill>
-                <a:latin typeface="Microsoft YaHei UI" panose="020B0503020204020204" pitchFamily="34" charset="-122"/>
-                <a:ea typeface="Microsoft YaHei UI" panose="020B0503020204020204" pitchFamily="34" charset="-122"/>
-              </a:rPr>
-              <a:t>PvE </a:t>
-            </a:r>
-            <a:r>
-              <a:rPr lang="zh-CN" altLang="en-US" sz="1050">
-                <a:solidFill>
-                  <a:srgbClr val="1E252C"/>
-                </a:solidFill>
-                <a:latin typeface="Microsoft YaHei UI" panose="020B0503020204020204" pitchFamily="34" charset="-122"/>
-                <a:ea typeface="Microsoft YaHei UI" panose="020B0503020204020204" pitchFamily="34" charset="-122"/>
-              </a:rPr>
-              <a:t>引导</a:t>
-            </a:r>
-          </a:p>
-        </p:txBody>
-      </p:sp>
-      <p:sp>
-        <p:nvSpPr>
-          <p:cNvPr id="114" name="矩形: 圆角 113">
-            <a:extLst>
-              <a:ext uri="{FF2B5EF4-FFF2-40B4-BE49-F238E27FC236}">
-                <a16:creationId xmlns:a16="http://schemas.microsoft.com/office/drawing/2014/main" id="{0C3A24F6-48E9-8924-D7AA-F1190D57884B}"/>
-              </a:ext>
-            </a:extLst>
-          </p:cNvPr>
-          <p:cNvSpPr/>
-          <p:nvPr/>
-        </p:nvSpPr>
-        <p:spPr>
-          <a:xfrm>
-            <a:off x="8128000" y="5689600"/>
-            <a:ext cx="3454400" cy="635000"/>
-          </a:xfrm>
-          <a:prstGeom prst="roundRect">
-            <a:avLst>
-              <a:gd name="adj" fmla="val 12000"/>
-            </a:avLst>
-          </a:prstGeom>
-          <a:solidFill>
-            <a:srgbClr val="EEF6EA"/>
-          </a:solidFill>
-          <a:ln w="19050" cap="flat" cmpd="sng" algn="ctr">
-            <a:noFill/>
-            <a:prstDash val="solid"/>
-            <a:miter lim="800000"/>
-          </a:ln>
-          <a:effectLst/>
-          <a:extLst>
-            <a:ext uri="{91240B29-F687-4F45-9708-019B960494DF}">
-              <a14:hiddenLine xmlns:a14="http://schemas.microsoft.com/office/drawing/2010/main" w="19050" cap="flat" cmpd="sng" algn="ctr">
-                <a:solidFill>
-                  <a:schemeClr val="accent1">
-                    <a:shade val="15000"/>
-                  </a:schemeClr>
-                </a:solidFill>
-                <a:prstDash val="solid"/>
-                <a:miter lim="800000"/>
-              </a14:hiddenLine>
-            </a:ext>
-          </a:extLst>
-        </p:spPr>
-        <p:style>
-          <a:lnRef idx="2">
-            <a:schemeClr val="accent1">
-              <a:shade val="15000"/>
-            </a:schemeClr>
-          </a:lnRef>
-          <a:fillRef idx="1">
-            <a:schemeClr val="accent1"/>
-          </a:fillRef>
-          <a:effectRef idx="0">
-            <a:schemeClr val="accent1"/>
-          </a:effectRef>
-          <a:fontRef idx="minor">
-            <a:schemeClr val="lt1"/>
-          </a:fontRef>
-        </p:style>
-        <p:txBody>
-          <a:bodyPr rtlCol="0" anchor="ctr"/>
-          <a:lstStyle/>
-          <a:p>
-            <a:pPr algn="ctr"/>
-            <a:endParaRPr lang="zh-CN" altLang="en-US"/>
-          </a:p>
-        </p:txBody>
-      </p:sp>
-      <p:sp>
-        <p:nvSpPr>
-          <p:cNvPr id="115" name="矩形: 圆角 114">
-            <a:extLst>
-              <a:ext uri="{FF2B5EF4-FFF2-40B4-BE49-F238E27FC236}">
-                <a16:creationId xmlns:a16="http://schemas.microsoft.com/office/drawing/2014/main" id="{015FF4A1-2D4E-1892-2C5D-9FC30FAE1C25}"/>
-              </a:ext>
-            </a:extLst>
-          </p:cNvPr>
-          <p:cNvSpPr/>
-          <p:nvPr/>
-        </p:nvSpPr>
-        <p:spPr>
-          <a:xfrm>
-            <a:off x="8305800" y="5867400"/>
-            <a:ext cx="571500" cy="279400"/>
-          </a:xfrm>
-          <a:prstGeom prst="roundRect">
-            <a:avLst>
-              <a:gd name="adj" fmla="val 50000"/>
-            </a:avLst>
-          </a:prstGeom>
-          <a:solidFill>
-            <a:srgbClr val="209A67"/>
-          </a:solidFill>
-          <a:ln w="19050" cap="flat" cmpd="sng" algn="ctr">
-            <a:noFill/>
-            <a:prstDash val="solid"/>
-            <a:miter lim="800000"/>
-          </a:ln>
-          <a:effectLst/>
-          <a:extLst>
-            <a:ext uri="{91240B29-F687-4F45-9708-019B960494DF}">
-              <a14:hiddenLine xmlns:a14="http://schemas.microsoft.com/office/drawing/2010/main" w="19050" cap="flat" cmpd="sng" algn="ctr">
-                <a:solidFill>
-                  <a:schemeClr val="accent1">
-                    <a:shade val="15000"/>
-                  </a:schemeClr>
-                </a:solidFill>
-                <a:prstDash val="solid"/>
-                <a:miter lim="800000"/>
-              </a14:hiddenLine>
-            </a:ext>
-          </a:extLst>
-        </p:spPr>
-        <p:style>
-          <a:lnRef idx="2">
-            <a:schemeClr val="accent1">
-              <a:shade val="15000"/>
-            </a:schemeClr>
-          </a:lnRef>
-          <a:fillRef idx="1">
-            <a:schemeClr val="accent1"/>
-          </a:fillRef>
-          <a:effectRef idx="0">
-            <a:schemeClr val="accent1"/>
-          </a:effectRef>
-          <a:fontRef idx="minor">
-            <a:schemeClr val="lt1"/>
-          </a:fontRef>
-        </p:style>
-        <p:txBody>
-          <a:bodyPr rtlCol="0" anchor="ctr"/>
-          <a:lstStyle/>
-          <a:p>
-            <a:pPr algn="ctr"/>
-            <a:endParaRPr lang="zh-CN" altLang="en-US"/>
-          </a:p>
-        </p:txBody>
-      </p:sp>
-      <p:sp>
-        <p:nvSpPr>
-          <p:cNvPr id="116" name="文本框 115">
-            <a:extLst>
-              <a:ext uri="{FF2B5EF4-FFF2-40B4-BE49-F238E27FC236}">
-                <a16:creationId xmlns:a16="http://schemas.microsoft.com/office/drawing/2014/main" id="{4DDEE7DE-F201-46FF-C356-02182B84284D}"/>
-              </a:ext>
-            </a:extLst>
-          </p:cNvPr>
-          <p:cNvSpPr txBox="1"/>
-          <p:nvPr/>
-        </p:nvSpPr>
-        <p:spPr>
-          <a:xfrm>
-            <a:off x="8305800" y="5918200"/>
-            <a:ext cx="571500" cy="130805"/>
-          </a:xfrm>
-          <a:prstGeom prst="rect">
-            <a:avLst/>
-          </a:prstGeom>
-          <a:noFill/>
-        </p:spPr>
-        <p:txBody>
-          <a:bodyPr vert="horz" wrap="square" lIns="0" tIns="0" rIns="0" bIns="0" rtlCol="0">
-            <a:spAutoFit/>
-          </a:bodyPr>
-          <a:lstStyle/>
-          <a:p>
-            <a:pPr algn="ctr"/>
-            <a:r>
-              <a:rPr lang="zh-CN" altLang="en-US" sz="850" b="1">
-                <a:solidFill>
-                  <a:srgbClr val="FFFFFF"/>
-                </a:solidFill>
-                <a:latin typeface="Microsoft YaHei UI" panose="020B0503020204020204" pitchFamily="34" charset="-122"/>
-                <a:ea typeface="Microsoft YaHei UI" panose="020B0503020204020204" pitchFamily="34" charset="-122"/>
-              </a:rPr>
-              <a:t>验证</a:t>
-            </a:r>
-          </a:p>
-        </p:txBody>
-      </p:sp>
-      <p:sp>
-        <p:nvSpPr>
-          <p:cNvPr id="117" name="文本框 116">
-            <a:extLst>
-              <a:ext uri="{FF2B5EF4-FFF2-40B4-BE49-F238E27FC236}">
-                <a16:creationId xmlns:a16="http://schemas.microsoft.com/office/drawing/2014/main" id="{9BF5B8D8-BE5B-C052-4AF4-9F86EE1DFDA0}"/>
-              </a:ext>
-            </a:extLst>
-          </p:cNvPr>
-          <p:cNvSpPr txBox="1"/>
-          <p:nvPr/>
-        </p:nvSpPr>
-        <p:spPr>
-          <a:xfrm>
-            <a:off x="9042400" y="5816600"/>
-            <a:ext cx="2336800" cy="323165"/>
-          </a:xfrm>
-          <a:prstGeom prst="rect">
-            <a:avLst/>
-          </a:prstGeom>
-          <a:noFill/>
-        </p:spPr>
-        <p:txBody>
-          <a:bodyPr vert="horz" wrap="square" lIns="0" tIns="0" rIns="0" bIns="0" rtlCol="0">
-            <a:spAutoFit/>
-          </a:bodyPr>
-          <a:lstStyle/>
-          <a:p>
-            <a:r>
-              <a:rPr lang="zh-CN" altLang="en-US" sz="1050">
-                <a:solidFill>
-                  <a:srgbClr val="1E252C"/>
-                </a:solidFill>
-                <a:latin typeface="Microsoft YaHei UI" panose="020B0503020204020204" pitchFamily="34" charset="-122"/>
-                <a:ea typeface="Microsoft YaHei UI" panose="020B0503020204020204" pitchFamily="34" charset="-122"/>
-              </a:rPr>
-              <a:t>内部大赛验证搜打撤闭环，再找老玩家复测</a:t>
-            </a:r>
+              <a:t>老玩家</a:t>
+            </a:r>
+            <a:endParaRPr lang="zh-CN" altLang="en-US" sz="1600" dirty="0"/>
           </a:p>
         </p:txBody>
       </p:sp>

</xml_diff>